<commit_message>
deploy: 2026-07-07 05:16 (build 20260707051612)
</commit_message>
<xml_diff>
--- a/cloudflare-deploy/public/library/student/student-en.pptx
+++ b/cloudflare-deploy/public/library/student/student-en.pptx
@@ -50,6 +50,9 @@
     <p:sldId id="298" r:id="rId49"/>
     <p:sldId id="299" r:id="rId50"/>
     <p:sldId id="300" r:id="rId51"/>
+    <p:sldId id="301" r:id="rId52"/>
+    <p:sldId id="302" r:id="rId53"/>
+    <p:sldId id="303" r:id="rId54"/>
   </p:sldIdLst>
   <p:sldSz cx="12191695" cy="6858000" type="screen4x3"/>
   <p:notesSz cx="6858000" cy="9144000"/>
@@ -35648,6 +35651,3019 @@
 </file>
 
 <file path=ppt/slides/slide40.xml><?xml version="1.0" encoding="utf-8"?>
+<p:sld xmlns:a="http://schemas.openxmlformats.org/drawingml/2006/main" xmlns:p="http://schemas.openxmlformats.org/presentationml/2006/main" xmlns:r="http://schemas.openxmlformats.org/officeDocument/2006/relationships">
+  <p:cSld>
+    <p:bg>
+      <p:bgPr>
+        <a:solidFill>
+          <a:srgbClr val="FFFFFF"/>
+        </a:solidFill>
+        <a:effectLst/>
+      </p:bgPr>
+    </p:bg>
+    <p:spTree>
+      <p:nvGrpSpPr>
+        <p:cNvPr id="1" name=""/>
+        <p:cNvGrpSpPr/>
+        <p:nvPr/>
+      </p:nvGrpSpPr>
+      <p:grpSpPr/>
+      <p:sp>
+        <p:nvSpPr>
+          <p:cNvPr id="2" name="Rectangle 1"/>
+          <p:cNvSpPr/>
+          <p:nvPr/>
+        </p:nvSpPr>
+        <p:spPr>
+          <a:xfrm>
+            <a:off x="0" y="0"/>
+            <a:ext cx="12191695" cy="566928"/>
+          </a:xfrm>
+          <a:prstGeom prst="rect">
+            <a:avLst/>
+          </a:prstGeom>
+          <a:solidFill>
+            <a:srgbClr val="7C3AED"/>
+          </a:solidFill>
+          <a:ln>
+            <a:noFill/>
+          </a:ln>
+          <a:effectLst/>
+        </p:spPr>
+        <p:style>
+          <a:lnRef idx="1">
+            <a:schemeClr val="accent1"/>
+          </a:lnRef>
+          <a:fillRef idx="3">
+            <a:schemeClr val="accent1"/>
+          </a:fillRef>
+          <a:effectRef idx="2">
+            <a:schemeClr val="accent1"/>
+          </a:effectRef>
+          <a:fontRef idx="minor">
+            <a:schemeClr val="lt1"/>
+          </a:fontRef>
+        </p:style>
+        <p:txBody>
+          <a:bodyPr rtlCol="0" anchor="ctr"/>
+          <a:lstStyle/>
+          <a:p>
+            <a:pPr algn="ctr"/>
+          </a:p>
+        </p:txBody>
+      </p:sp>
+      <p:sp>
+        <p:nvSpPr>
+          <p:cNvPr id="3" name="Rectangle 2"/>
+          <p:cNvSpPr/>
+          <p:nvPr/>
+        </p:nvSpPr>
+        <p:spPr>
+          <a:xfrm>
+            <a:off x="0" y="566928"/>
+            <a:ext cx="12191695" cy="54864"/>
+          </a:xfrm>
+          <a:prstGeom prst="rect">
+            <a:avLst/>
+          </a:prstGeom>
+          <a:solidFill>
+            <a:srgbClr val="FF9F1C"/>
+          </a:solidFill>
+          <a:ln>
+            <a:noFill/>
+          </a:ln>
+          <a:effectLst/>
+        </p:spPr>
+        <p:style>
+          <a:lnRef idx="1">
+            <a:schemeClr val="accent1"/>
+          </a:lnRef>
+          <a:fillRef idx="3">
+            <a:schemeClr val="accent1"/>
+          </a:fillRef>
+          <a:effectRef idx="2">
+            <a:schemeClr val="accent1"/>
+          </a:effectRef>
+          <a:fontRef idx="minor">
+            <a:schemeClr val="lt1"/>
+          </a:fontRef>
+        </p:style>
+        <p:txBody>
+          <a:bodyPr rtlCol="0" anchor="ctr"/>
+          <a:lstStyle/>
+          <a:p>
+            <a:pPr algn="ctr"/>
+          </a:p>
+        </p:txBody>
+      </p:sp>
+      <p:sp>
+        <p:nvSpPr>
+          <p:cNvPr id="4" name="TextBox 3"/>
+          <p:cNvSpPr txBox="1"/>
+          <p:nvPr/>
+        </p:nvSpPr>
+        <p:spPr>
+          <a:xfrm>
+            <a:off x="365760" y="27432"/>
+            <a:ext cx="7315200" cy="502920"/>
+          </a:xfrm>
+          <a:prstGeom prst="rect">
+            <a:avLst/>
+          </a:prstGeom>
+          <a:noFill/>
+        </p:spPr>
+        <p:txBody>
+          <a:bodyPr wrap="square" anchor="ctr">
+            <a:spAutoFit/>
+          </a:bodyPr>
+          <a:lstStyle/>
+          <a:p>
+            <a:pPr algn="l">
+              <a:lnSpc>
+                <a:spcPct val="100000"/>
+              </a:lnSpc>
+            </a:pPr>
+            <a:r>
+              <a:rPr sz="1500" b="1">
+                <a:solidFill>
+                  <a:srgbClr val="FFFFFF"/>
+                </a:solidFill>
+                <a:latin typeface="Malgun Gothic"/>
+              </a:rPr>
+              <a:t>🎒 Mangoi Student User Guide</a:t>
+            </a:r>
+          </a:p>
+        </p:txBody>
+      </p:sp>
+      <p:sp>
+        <p:nvSpPr>
+          <p:cNvPr id="5" name="TextBox 4"/>
+          <p:cNvSpPr txBox="1"/>
+          <p:nvPr/>
+        </p:nvSpPr>
+        <p:spPr>
+          <a:xfrm>
+            <a:off x="8168335" y="27432"/>
+            <a:ext cx="3657600" cy="502920"/>
+          </a:xfrm>
+          <a:prstGeom prst="rect">
+            <a:avLst/>
+          </a:prstGeom>
+          <a:noFill/>
+        </p:spPr>
+        <p:txBody>
+          <a:bodyPr wrap="square" anchor="ctr">
+            <a:spAutoFit/>
+          </a:bodyPr>
+          <a:lstStyle/>
+          <a:p>
+            <a:pPr algn="r">
+              <a:lnSpc>
+                <a:spcPct val="100000"/>
+              </a:lnSpc>
+            </a:pPr>
+            <a:r>
+              <a:rPr sz="1300" b="1">
+                <a:solidFill>
+                  <a:srgbClr val="F1F5F9"/>
+                </a:solidFill>
+                <a:latin typeface="Malgun Gothic"/>
+              </a:rPr>
+              <a:t>How to Use the Main Features</a:t>
+            </a:r>
+          </a:p>
+        </p:txBody>
+      </p:sp>
+      <p:sp>
+        <p:nvSpPr>
+          <p:cNvPr id="6" name="Rounded Rectangle 5"/>
+          <p:cNvSpPr/>
+          <p:nvPr/>
+        </p:nvSpPr>
+        <p:spPr>
+          <a:xfrm>
+            <a:off x="365760" y="822960"/>
+            <a:ext cx="868680" cy="868680"/>
+          </a:xfrm>
+          <a:prstGeom prst="roundRect">
+            <a:avLst/>
+          </a:prstGeom>
+          <a:solidFill>
+            <a:srgbClr val="7C3AED"/>
+          </a:solidFill>
+          <a:ln>
+            <a:noFill/>
+          </a:ln>
+          <a:effectLst/>
+        </p:spPr>
+        <p:style>
+          <a:lnRef idx="1">
+            <a:schemeClr val="accent1"/>
+          </a:lnRef>
+          <a:fillRef idx="3">
+            <a:schemeClr val="accent1"/>
+          </a:fillRef>
+          <a:effectRef idx="2">
+            <a:schemeClr val="accent1"/>
+          </a:effectRef>
+          <a:fontRef idx="minor">
+            <a:schemeClr val="lt1"/>
+          </a:fontRef>
+        </p:style>
+        <p:txBody>
+          <a:bodyPr rtlCol="0" anchor="ctr"/>
+          <a:lstStyle/>
+          <a:p>
+            <a:pPr algn="ctr"/>
+          </a:p>
+        </p:txBody>
+      </p:sp>
+      <p:sp>
+        <p:nvSpPr>
+          <p:cNvPr id="7" name="TextBox 6"/>
+          <p:cNvSpPr txBox="1"/>
+          <p:nvPr/>
+        </p:nvSpPr>
+        <p:spPr>
+          <a:xfrm>
+            <a:off x="365760" y="822960"/>
+            <a:ext cx="868680" cy="868680"/>
+          </a:xfrm>
+          <a:prstGeom prst="rect">
+            <a:avLst/>
+          </a:prstGeom>
+          <a:noFill/>
+        </p:spPr>
+        <p:txBody>
+          <a:bodyPr wrap="square" anchor="ctr">
+            <a:spAutoFit/>
+          </a:bodyPr>
+          <a:lstStyle/>
+          <a:p>
+            <a:pPr algn="ctr">
+              <a:lnSpc>
+                <a:spcPct val="100000"/>
+              </a:lnSpc>
+            </a:pPr>
+            <a:r>
+              <a:rPr sz="2600" b="1">
+                <a:solidFill>
+                  <a:srgbClr val="FFFFFF"/>
+                </a:solidFill>
+                <a:latin typeface="Malgun Gothic"/>
+              </a:rPr>
+              <a:t>38</a:t>
+            </a:r>
+          </a:p>
+        </p:txBody>
+      </p:sp>
+      <p:sp>
+        <p:nvSpPr>
+          <p:cNvPr id="8" name="TextBox 7"/>
+          <p:cNvSpPr txBox="1"/>
+          <p:nvPr/>
+        </p:nvSpPr>
+        <p:spPr>
+          <a:xfrm>
+            <a:off x="1371600" y="822960"/>
+            <a:ext cx="10424160" cy="502920"/>
+          </a:xfrm>
+          <a:prstGeom prst="rect">
+            <a:avLst/>
+          </a:prstGeom>
+          <a:noFill/>
+        </p:spPr>
+        <p:txBody>
+          <a:bodyPr wrap="square" anchor="t">
+            <a:spAutoFit/>
+          </a:bodyPr>
+          <a:lstStyle/>
+          <a:p>
+            <a:pPr algn="l">
+              <a:lnSpc>
+                <a:spcPct val="100000"/>
+              </a:lnSpc>
+            </a:pPr>
+            <a:r>
+              <a:rPr sz="2300" b="1">
+                <a:solidFill>
+                  <a:srgbClr val="1E2340"/>
+                </a:solidFill>
+                <a:latin typeface="Malgun Gothic"/>
+              </a:rPr>
+              <a:t>📔 AI Voice Diary</a:t>
+            </a:r>
+          </a:p>
+        </p:txBody>
+      </p:sp>
+      <p:sp>
+        <p:nvSpPr>
+          <p:cNvPr id="9" name="TextBox 8"/>
+          <p:cNvSpPr txBox="1"/>
+          <p:nvPr/>
+        </p:nvSpPr>
+        <p:spPr>
+          <a:xfrm>
+            <a:off x="1417320" y="1353312"/>
+            <a:ext cx="10424160" cy="320040"/>
+          </a:xfrm>
+          <a:prstGeom prst="rect">
+            <a:avLst/>
+          </a:prstGeom>
+          <a:noFill/>
+        </p:spPr>
+        <p:txBody>
+          <a:bodyPr wrap="square" anchor="t">
+            <a:spAutoFit/>
+          </a:bodyPr>
+          <a:lstStyle/>
+          <a:p>
+            <a:pPr algn="l">
+              <a:lnSpc>
+                <a:spcPct val="100000"/>
+              </a:lnSpc>
+            </a:pPr>
+            <a:r>
+              <a:rPr sz="1300" b="0">
+                <a:solidFill>
+                  <a:srgbClr val="64748B"/>
+                </a:solidFill>
+                <a:latin typeface="Malgun Gothic"/>
+              </a:rPr>
+              <a:t>Speak about your day in English and AI corrects it</a:t>
+            </a:r>
+          </a:p>
+        </p:txBody>
+      </p:sp>
+      <p:sp>
+        <p:nvSpPr>
+          <p:cNvPr id="10" name="Rounded Rectangle 9"/>
+          <p:cNvSpPr/>
+          <p:nvPr/>
+        </p:nvSpPr>
+        <p:spPr>
+          <a:xfrm>
+            <a:off x="365760" y="1828800"/>
+            <a:ext cx="11430000" cy="777240"/>
+          </a:xfrm>
+          <a:prstGeom prst="roundRect">
+            <a:avLst/>
+          </a:prstGeom>
+          <a:solidFill>
+            <a:srgbClr val="F3F0FF"/>
+          </a:solidFill>
+          <a:ln>
+            <a:noFill/>
+          </a:ln>
+          <a:effectLst/>
+        </p:spPr>
+        <p:style>
+          <a:lnRef idx="1">
+            <a:schemeClr val="accent1"/>
+          </a:lnRef>
+          <a:fillRef idx="3">
+            <a:schemeClr val="accent1"/>
+          </a:fillRef>
+          <a:effectRef idx="2">
+            <a:schemeClr val="accent1"/>
+          </a:effectRef>
+          <a:fontRef idx="minor">
+            <a:schemeClr val="lt1"/>
+          </a:fontRef>
+        </p:style>
+        <p:txBody>
+          <a:bodyPr rtlCol="0" anchor="ctr"/>
+          <a:lstStyle/>
+          <a:p>
+            <a:pPr algn="ctr"/>
+          </a:p>
+        </p:txBody>
+      </p:sp>
+      <p:sp>
+        <p:nvSpPr>
+          <p:cNvPr id="11" name="TextBox 10"/>
+          <p:cNvSpPr txBox="1"/>
+          <p:nvPr/>
+        </p:nvSpPr>
+        <p:spPr>
+          <a:xfrm>
+            <a:off x="548640" y="1901952"/>
+            <a:ext cx="11064240" cy="640080"/>
+          </a:xfrm>
+          <a:prstGeom prst="rect">
+            <a:avLst/>
+          </a:prstGeom>
+          <a:noFill/>
+        </p:spPr>
+        <p:txBody>
+          <a:bodyPr wrap="square" anchor="t">
+            <a:spAutoFit/>
+          </a:bodyPr>
+          <a:lstStyle/>
+          <a:p>
+            <a:pPr algn="l">
+              <a:lnSpc>
+                <a:spcPct val="115000"/>
+              </a:lnSpc>
+            </a:pPr>
+            <a:r>
+              <a:rPr sz="1200" b="0">
+                <a:solidFill>
+                  <a:srgbClr val="334155"/>
+                </a:solidFill>
+                <a:latin typeface="Malgun Gothic"/>
+              </a:rPr>
+              <a:t>Say what happened today in English, and AI transcribes your speech, polishes the sentences, and leaves a score and encouragement. A little every day builds your own English diary!</a:t>
+            </a:r>
+          </a:p>
+        </p:txBody>
+      </p:sp>
+      <p:sp>
+        <p:nvSpPr>
+          <p:cNvPr id="12" name="TextBox 11"/>
+          <p:cNvSpPr txBox="1"/>
+          <p:nvPr/>
+        </p:nvSpPr>
+        <p:spPr>
+          <a:xfrm>
+            <a:off x="457200" y="2743200"/>
+            <a:ext cx="5669280" cy="320040"/>
+          </a:xfrm>
+          <a:prstGeom prst="rect">
+            <a:avLst/>
+          </a:prstGeom>
+          <a:noFill/>
+        </p:spPr>
+        <p:txBody>
+          <a:bodyPr wrap="square" anchor="t">
+            <a:spAutoFit/>
+          </a:bodyPr>
+          <a:lstStyle/>
+          <a:p>
+            <a:pPr algn="l">
+              <a:lnSpc>
+                <a:spcPct val="100000"/>
+              </a:lnSpc>
+            </a:pPr>
+            <a:r>
+              <a:rPr sz="1350" b="1">
+                <a:solidFill>
+                  <a:srgbClr val="7C3AED"/>
+                </a:solidFill>
+                <a:latin typeface="Malgun Gothic"/>
+              </a:rPr>
+              <a:t>How to use</a:t>
+            </a:r>
+          </a:p>
+        </p:txBody>
+      </p:sp>
+      <p:sp>
+        <p:nvSpPr>
+          <p:cNvPr id="13" name="TextBox 12"/>
+          <p:cNvSpPr txBox="1"/>
+          <p:nvPr/>
+        </p:nvSpPr>
+        <p:spPr>
+          <a:xfrm>
+            <a:off x="457200" y="3108960"/>
+            <a:ext cx="5669280" cy="2377440"/>
+          </a:xfrm>
+          <a:prstGeom prst="rect">
+            <a:avLst/>
+          </a:prstGeom>
+          <a:noFill/>
+        </p:spPr>
+        <p:txBody>
+          <a:bodyPr wrap="square">
+            <a:spAutoFit/>
+          </a:bodyPr>
+          <a:lstStyle/>
+          <a:p>
+            <a:pPr>
+              <a:lnSpc>
+                <a:spcPct val="115000"/>
+              </a:lnSpc>
+              <a:spcAft>
+                <a:spcPts val="600"/>
+              </a:spcAft>
+            </a:pPr>
+            <a:r>
+              <a:rPr sz="1050" b="1">
+                <a:solidFill>
+                  <a:srgbClr val="7C3AED"/>
+                </a:solidFill>
+                <a:latin typeface="Malgun Gothic"/>
+              </a:rPr>
+              <a:t>● </a:t>
+            </a:r>
+            <a:r>
+              <a:rPr sz="1250">
+                <a:solidFill>
+                  <a:srgbClr val="334155"/>
+                </a:solidFill>
+                <a:latin typeface="Malgun Gothic"/>
+              </a:rPr>
+              <a:t>On the home menu, tap the 📔 AI Voice Diary card (next to the English/Chinese pronunciation coach).</a:t>
+            </a:r>
+          </a:p>
+          <a:p>
+            <a:pPr>
+              <a:lnSpc>
+                <a:spcPct val="115000"/>
+              </a:lnSpc>
+              <a:spcAft>
+                <a:spcPts val="600"/>
+              </a:spcAft>
+            </a:pPr>
+            <a:r>
+              <a:rPr sz="1050" b="1">
+                <a:solidFill>
+                  <a:srgbClr val="7C3AED"/>
+                </a:solidFill>
+                <a:latin typeface="Malgun Gothic"/>
+              </a:rPr>
+              <a:t>● </a:t>
+            </a:r>
+            <a:r>
+              <a:rPr sz="1250">
+                <a:solidFill>
+                  <a:srgbClr val="334155"/>
+                </a:solidFill>
+                <a:latin typeface="Malgun Gothic"/>
+              </a:rPr>
+              <a:t>In the 🎤 Record tab, press ‘Start recording’ and talk about your day in English (about 30 seconds is plenty!).</a:t>
+            </a:r>
+          </a:p>
+          <a:p>
+            <a:pPr>
+              <a:lnSpc>
+                <a:spcPct val="115000"/>
+              </a:lnSpc>
+              <a:spcAft>
+                <a:spcPts val="600"/>
+              </a:spcAft>
+            </a:pPr>
+            <a:r>
+              <a:rPr sz="1050" b="1">
+                <a:solidFill>
+                  <a:srgbClr val="7C3AED"/>
+                </a:solidFill>
+                <a:latin typeface="Malgun Gothic"/>
+              </a:rPr>
+              <a:t>● </a:t>
+            </a:r>
+            <a:r>
+              <a:rPr sz="1250">
+                <a:solidFill>
+                  <a:srgbClr val="334155"/>
+                </a:solidFill>
+                <a:latin typeface="Malgun Gothic"/>
+              </a:rPr>
+              <a:t>Press ‘Stop’ and AI automatically does transcribe → correct → score &amp; encourage.</a:t>
+            </a:r>
+          </a:p>
+          <a:p>
+            <a:pPr>
+              <a:lnSpc>
+                <a:spcPct val="115000"/>
+              </a:lnSpc>
+              <a:spcAft>
+                <a:spcPts val="600"/>
+              </a:spcAft>
+            </a:pPr>
+            <a:r>
+              <a:rPr sz="1050" b="1">
+                <a:solidFill>
+                  <a:srgbClr val="7C3AED"/>
+                </a:solidFill>
+                <a:latin typeface="Malgun Gothic"/>
+              </a:rPr>
+              <a:t>● </a:t>
+            </a:r>
+            <a:r>
+              <a:rPr sz="1250">
+                <a:solidFill>
+                  <a:srgbClr val="334155"/>
+                </a:solidFill>
+                <a:latin typeface="Malgun Gothic"/>
+              </a:rPr>
+              <a:t>The 📅 Calendar tab lets you revisit past entries by date.</a:t>
+            </a:r>
+          </a:p>
+        </p:txBody>
+      </p:sp>
+      <p:sp>
+        <p:nvSpPr>
+          <p:cNvPr id="14" name="Rounded Rectangle 13"/>
+          <p:cNvSpPr/>
+          <p:nvPr/>
+        </p:nvSpPr>
+        <p:spPr>
+          <a:xfrm>
+            <a:off x="457200" y="4782312"/>
+            <a:ext cx="5669280" cy="1316736"/>
+          </a:xfrm>
+          <a:prstGeom prst="roundRect">
+            <a:avLst/>
+          </a:prstGeom>
+          <a:solidFill>
+            <a:srgbClr val="F4F7FF"/>
+          </a:solidFill>
+          <a:ln w="12700">
+            <a:solidFill>
+              <a:srgbClr val="7C3AED"/>
+            </a:solidFill>
+          </a:ln>
+          <a:effectLst/>
+        </p:spPr>
+        <p:style>
+          <a:lnRef idx="1">
+            <a:schemeClr val="accent1"/>
+          </a:lnRef>
+          <a:fillRef idx="3">
+            <a:schemeClr val="accent1"/>
+          </a:fillRef>
+          <a:effectRef idx="2">
+            <a:schemeClr val="accent1"/>
+          </a:effectRef>
+          <a:fontRef idx="minor">
+            <a:schemeClr val="lt1"/>
+          </a:fontRef>
+        </p:style>
+        <p:txBody>
+          <a:bodyPr rtlCol="0" anchor="ctr"/>
+          <a:lstStyle/>
+          <a:p>
+            <a:pPr algn="ctr"/>
+          </a:p>
+        </p:txBody>
+      </p:sp>
+      <p:sp>
+        <p:nvSpPr>
+          <p:cNvPr id="15" name="TextBox 14"/>
+          <p:cNvSpPr txBox="1"/>
+          <p:nvPr/>
+        </p:nvSpPr>
+        <p:spPr>
+          <a:xfrm>
+            <a:off x="594360" y="4837175"/>
+            <a:ext cx="5394960" cy="274320"/>
+          </a:xfrm>
+          <a:prstGeom prst="rect">
+            <a:avLst/>
+          </a:prstGeom>
+          <a:noFill/>
+        </p:spPr>
+        <p:txBody>
+          <a:bodyPr wrap="square" anchor="t">
+            <a:spAutoFit/>
+          </a:bodyPr>
+          <a:lstStyle/>
+          <a:p>
+            <a:pPr algn="l">
+              <a:lnSpc>
+                <a:spcPct val="100000"/>
+              </a:lnSpc>
+            </a:pPr>
+            <a:r>
+              <a:rPr sz="1150" b="1">
+                <a:solidFill>
+                  <a:srgbClr val="7C3AED"/>
+                </a:solidFill>
+                <a:latin typeface="Malgun Gothic"/>
+              </a:rPr>
+              <a:t>✅ Key Points</a:t>
+            </a:r>
+          </a:p>
+        </p:txBody>
+      </p:sp>
+      <p:sp>
+        <p:nvSpPr>
+          <p:cNvPr id="16" name="TextBox 15"/>
+          <p:cNvSpPr txBox="1"/>
+          <p:nvPr/>
+        </p:nvSpPr>
+        <p:spPr>
+          <a:xfrm>
+            <a:off x="594360" y="5111496"/>
+            <a:ext cx="5394960" cy="950976"/>
+          </a:xfrm>
+          <a:prstGeom prst="rect">
+            <a:avLst/>
+          </a:prstGeom>
+          <a:noFill/>
+        </p:spPr>
+        <p:txBody>
+          <a:bodyPr wrap="square">
+            <a:spAutoFit/>
+          </a:bodyPr>
+          <a:lstStyle/>
+          <a:p>
+            <a:pPr>
+              <a:lnSpc>
+                <a:spcPct val="115000"/>
+              </a:lnSpc>
+              <a:spcAft>
+                <a:spcPts val="200"/>
+              </a:spcAft>
+            </a:pPr>
+            <a:r>
+              <a:rPr sz="900" b="1">
+                <a:solidFill>
+                  <a:srgbClr val="7C3AED"/>
+                </a:solidFill>
+                <a:latin typeface="Malgun Gothic"/>
+              </a:rPr>
+              <a:t>● </a:t>
+            </a:r>
+            <a:r>
+              <a:rPr sz="1100">
+                <a:solidFill>
+                  <a:srgbClr val="334155"/>
+                </a:solidFill>
+                <a:latin typeface="Malgun Gothic"/>
+              </a:rPr>
+              <a:t>Turns your spoken English into text and rewrites awkward sentences naturally.</a:t>
+            </a:r>
+          </a:p>
+          <a:p>
+            <a:pPr>
+              <a:lnSpc>
+                <a:spcPct val="115000"/>
+              </a:lnSpc>
+              <a:spcAft>
+                <a:spcPts val="200"/>
+              </a:spcAft>
+            </a:pPr>
+            <a:r>
+              <a:rPr sz="900" b="1">
+                <a:solidFill>
+                  <a:srgbClr val="7C3AED"/>
+                </a:solidFill>
+                <a:latin typeface="Malgun Gothic"/>
+              </a:rPr>
+              <a:t>● </a:t>
+            </a:r>
+            <a:r>
+              <a:rPr sz="1100">
+                <a:solidFill>
+                  <a:srgbClr val="334155"/>
+                </a:solidFill>
+                <a:latin typeface="Malgun Gothic"/>
+              </a:rPr>
+              <a:t>A score (0–100) and a word of encouragement keep you motivated daily.</a:t>
+            </a:r>
+          </a:p>
+          <a:p>
+            <a:pPr>
+              <a:lnSpc>
+                <a:spcPct val="115000"/>
+              </a:lnSpc>
+              <a:spcAft>
+                <a:spcPts val="200"/>
+              </a:spcAft>
+            </a:pPr>
+            <a:r>
+              <a:rPr sz="900" b="1">
+                <a:solidFill>
+                  <a:srgbClr val="7C3AED"/>
+                </a:solidFill>
+                <a:latin typeface="Malgun Gothic"/>
+              </a:rPr>
+              <a:t>● </a:t>
+            </a:r>
+            <a:r>
+              <a:rPr sz="1100">
+                <a:solidFill>
+                  <a:srgbClr val="334155"/>
+                </a:solidFill>
+                <a:latin typeface="Malgun Gothic"/>
+              </a:rPr>
+              <a:t>Doing it daily also connects to attendance streaks and badges.</a:t>
+            </a:r>
+          </a:p>
+        </p:txBody>
+      </p:sp>
+      <p:sp>
+        <p:nvSpPr>
+          <p:cNvPr id="17" name="Rounded Rectangle 16"/>
+          <p:cNvSpPr/>
+          <p:nvPr/>
+        </p:nvSpPr>
+        <p:spPr>
+          <a:xfrm>
+            <a:off x="457200" y="6208775"/>
+            <a:ext cx="5669280" cy="640080"/>
+          </a:xfrm>
+          <a:prstGeom prst="roundRect">
+            <a:avLst/>
+          </a:prstGeom>
+          <a:solidFill>
+            <a:srgbClr val="FFFBEB"/>
+          </a:solidFill>
+          <a:ln w="12700">
+            <a:solidFill>
+              <a:srgbClr val="F59E0B"/>
+            </a:solidFill>
+          </a:ln>
+          <a:effectLst/>
+        </p:spPr>
+        <p:style>
+          <a:lnRef idx="1">
+            <a:schemeClr val="accent1"/>
+          </a:lnRef>
+          <a:fillRef idx="3">
+            <a:schemeClr val="accent1"/>
+          </a:fillRef>
+          <a:effectRef idx="2">
+            <a:schemeClr val="accent1"/>
+          </a:effectRef>
+          <a:fontRef idx="minor">
+            <a:schemeClr val="lt1"/>
+          </a:fontRef>
+        </p:style>
+        <p:txBody>
+          <a:bodyPr rtlCol="0" anchor="ctr"/>
+          <a:lstStyle/>
+          <a:p>
+            <a:pPr algn="ctr"/>
+          </a:p>
+        </p:txBody>
+      </p:sp>
+      <p:sp>
+        <p:nvSpPr>
+          <p:cNvPr id="18" name="TextBox 17"/>
+          <p:cNvSpPr txBox="1"/>
+          <p:nvPr/>
+        </p:nvSpPr>
+        <p:spPr>
+          <a:xfrm>
+            <a:off x="594360" y="6254495"/>
+            <a:ext cx="5394960" cy="548640"/>
+          </a:xfrm>
+          <a:prstGeom prst="rect">
+            <a:avLst/>
+          </a:prstGeom>
+          <a:noFill/>
+        </p:spPr>
+        <p:txBody>
+          <a:bodyPr wrap="square" anchor="t">
+            <a:spAutoFit/>
+          </a:bodyPr>
+          <a:lstStyle/>
+          <a:p>
+            <a:pPr algn="l">
+              <a:lnSpc>
+                <a:spcPct val="105000"/>
+              </a:lnSpc>
+            </a:pPr>
+            <a:r>
+              <a:rPr sz="1050" b="0">
+                <a:solidFill>
+                  <a:srgbClr val="92670A"/>
+                </a:solidFill>
+                <a:latin typeface="Malgun Gothic"/>
+              </a:rPr>
+              <a:t>⚠️ Good to know · Recording requires you to be logged in. Speaking clearly in a quiet place makes the transcription more accurate.</a:t>
+            </a:r>
+          </a:p>
+        </p:txBody>
+      </p:sp>
+      <p:sp>
+        <p:nvSpPr>
+          <p:cNvPr id="19" name="Rounded Rectangle 18"/>
+          <p:cNvSpPr/>
+          <p:nvPr/>
+        </p:nvSpPr>
+        <p:spPr>
+          <a:xfrm>
+            <a:off x="457200" y="6940295"/>
+            <a:ext cx="5669280" cy="658368"/>
+          </a:xfrm>
+          <a:prstGeom prst="roundRect">
+            <a:avLst/>
+          </a:prstGeom>
+          <a:solidFill>
+            <a:srgbClr val="FFF7E6"/>
+          </a:solidFill>
+          <a:ln w="12700">
+            <a:solidFill>
+              <a:srgbClr val="FF9F1C"/>
+            </a:solidFill>
+          </a:ln>
+          <a:effectLst/>
+        </p:spPr>
+        <p:style>
+          <a:lnRef idx="1">
+            <a:schemeClr val="accent1"/>
+          </a:lnRef>
+          <a:fillRef idx="3">
+            <a:schemeClr val="accent1"/>
+          </a:fillRef>
+          <a:effectRef idx="2">
+            <a:schemeClr val="accent1"/>
+          </a:effectRef>
+          <a:fontRef idx="minor">
+            <a:schemeClr val="lt1"/>
+          </a:fontRef>
+        </p:style>
+        <p:txBody>
+          <a:bodyPr rtlCol="0" anchor="ctr"/>
+          <a:lstStyle/>
+          <a:p>
+            <a:pPr algn="ctr"/>
+          </a:p>
+        </p:txBody>
+      </p:sp>
+      <p:sp>
+        <p:nvSpPr>
+          <p:cNvPr id="20" name="TextBox 19"/>
+          <p:cNvSpPr txBox="1"/>
+          <p:nvPr/>
+        </p:nvSpPr>
+        <p:spPr>
+          <a:xfrm>
+            <a:off x="594360" y="6986015"/>
+            <a:ext cx="5394960" cy="566928"/>
+          </a:xfrm>
+          <a:prstGeom prst="rect">
+            <a:avLst/>
+          </a:prstGeom>
+          <a:noFill/>
+        </p:spPr>
+        <p:txBody>
+          <a:bodyPr wrap="square" anchor="t">
+            <a:spAutoFit/>
+          </a:bodyPr>
+          <a:lstStyle/>
+          <a:p>
+            <a:pPr algn="l">
+              <a:lnSpc>
+                <a:spcPct val="105000"/>
+              </a:lnSpc>
+            </a:pPr>
+            <a:r>
+              <a:rPr sz="1050" b="0">
+                <a:solidFill>
+                  <a:srgbClr val="5B4A2A"/>
+                </a:solidFill>
+                <a:latin typeface="Malgun Gothic"/>
+              </a:rPr>
+              <a:t>💡 Tip · It doesn't have to be perfect. The habit of saying even ‘one sentence’ a day matters most!</a:t>
+            </a:r>
+          </a:p>
+        </p:txBody>
+      </p:sp>
+      <p:sp>
+        <p:nvSpPr>
+          <p:cNvPr id="21" name="Rectangle 20"/>
+          <p:cNvSpPr/>
+          <p:nvPr/>
+        </p:nvSpPr>
+        <p:spPr>
+          <a:xfrm>
+            <a:off x="6300216" y="2345436"/>
+            <a:ext cx="5596128" cy="3538728"/>
+          </a:xfrm>
+          <a:prstGeom prst="rect">
+            <a:avLst/>
+          </a:prstGeom>
+          <a:solidFill>
+            <a:srgbClr val="FFFFFF"/>
+          </a:solidFill>
+          <a:ln w="12700">
+            <a:solidFill>
+              <a:srgbClr val="E2E8F0"/>
+            </a:solidFill>
+          </a:ln>
+          <a:effectLst/>
+        </p:spPr>
+        <p:style>
+          <a:lnRef idx="1">
+            <a:schemeClr val="accent1"/>
+          </a:lnRef>
+          <a:fillRef idx="3">
+            <a:schemeClr val="accent1"/>
+          </a:fillRef>
+          <a:effectRef idx="2">
+            <a:schemeClr val="accent1"/>
+          </a:effectRef>
+          <a:fontRef idx="minor">
+            <a:schemeClr val="lt1"/>
+          </a:fontRef>
+        </p:style>
+        <p:txBody>
+          <a:bodyPr rtlCol="0" anchor="ctr"/>
+          <a:lstStyle/>
+          <a:p>
+            <a:pPr algn="ctr"/>
+          </a:p>
+        </p:txBody>
+      </p:sp>
+      <p:pic>
+        <p:nvPicPr>
+          <p:cNvPr id="22" name="Picture 21" descr="student_voicediary.jpg"/>
+          <p:cNvPicPr>
+            <a:picLocks noChangeAspect="1"/>
+          </p:cNvPicPr>
+          <p:nvPr/>
+        </p:nvPicPr>
+        <p:blipFill>
+          <a:blip r:embed="rId2"/>
+          <a:stretch>
+            <a:fillRect/>
+          </a:stretch>
+        </p:blipFill>
+        <p:spPr>
+          <a:xfrm>
+            <a:off x="6355080" y="2400300"/>
+            <a:ext cx="5486400" cy="3429000"/>
+          </a:xfrm>
+          <a:prstGeom prst="rect">
+            <a:avLst/>
+          </a:prstGeom>
+        </p:spPr>
+      </p:pic>
+    </p:spTree>
+  </p:cSld>
+  <p:clrMapOvr>
+    <a:masterClrMapping/>
+  </p:clrMapOvr>
+</p:sld>
+</file>
+
+<file path=ppt/slides/slide41.xml><?xml version="1.0" encoding="utf-8"?>
+<p:sld xmlns:a="http://schemas.openxmlformats.org/drawingml/2006/main" xmlns:p="http://schemas.openxmlformats.org/presentationml/2006/main" xmlns:r="http://schemas.openxmlformats.org/officeDocument/2006/relationships">
+  <p:cSld>
+    <p:bg>
+      <p:bgPr>
+        <a:solidFill>
+          <a:srgbClr val="FFFFFF"/>
+        </a:solidFill>
+        <a:effectLst/>
+      </p:bgPr>
+    </p:bg>
+    <p:spTree>
+      <p:nvGrpSpPr>
+        <p:cNvPr id="1" name=""/>
+        <p:cNvGrpSpPr/>
+        <p:nvPr/>
+      </p:nvGrpSpPr>
+      <p:grpSpPr/>
+      <p:sp>
+        <p:nvSpPr>
+          <p:cNvPr id="2" name="Rectangle 1"/>
+          <p:cNvSpPr/>
+          <p:nvPr/>
+        </p:nvSpPr>
+        <p:spPr>
+          <a:xfrm>
+            <a:off x="0" y="0"/>
+            <a:ext cx="12191695" cy="566928"/>
+          </a:xfrm>
+          <a:prstGeom prst="rect">
+            <a:avLst/>
+          </a:prstGeom>
+          <a:solidFill>
+            <a:srgbClr val="7C3AED"/>
+          </a:solidFill>
+          <a:ln>
+            <a:noFill/>
+          </a:ln>
+          <a:effectLst/>
+        </p:spPr>
+        <p:style>
+          <a:lnRef idx="1">
+            <a:schemeClr val="accent1"/>
+          </a:lnRef>
+          <a:fillRef idx="3">
+            <a:schemeClr val="accent1"/>
+          </a:fillRef>
+          <a:effectRef idx="2">
+            <a:schemeClr val="accent1"/>
+          </a:effectRef>
+          <a:fontRef idx="minor">
+            <a:schemeClr val="lt1"/>
+          </a:fontRef>
+        </p:style>
+        <p:txBody>
+          <a:bodyPr rtlCol="0" anchor="ctr"/>
+          <a:lstStyle/>
+          <a:p>
+            <a:pPr algn="ctr"/>
+          </a:p>
+        </p:txBody>
+      </p:sp>
+      <p:sp>
+        <p:nvSpPr>
+          <p:cNvPr id="3" name="Rectangle 2"/>
+          <p:cNvSpPr/>
+          <p:nvPr/>
+        </p:nvSpPr>
+        <p:spPr>
+          <a:xfrm>
+            <a:off x="0" y="566928"/>
+            <a:ext cx="12191695" cy="54864"/>
+          </a:xfrm>
+          <a:prstGeom prst="rect">
+            <a:avLst/>
+          </a:prstGeom>
+          <a:solidFill>
+            <a:srgbClr val="FF9F1C"/>
+          </a:solidFill>
+          <a:ln>
+            <a:noFill/>
+          </a:ln>
+          <a:effectLst/>
+        </p:spPr>
+        <p:style>
+          <a:lnRef idx="1">
+            <a:schemeClr val="accent1"/>
+          </a:lnRef>
+          <a:fillRef idx="3">
+            <a:schemeClr val="accent1"/>
+          </a:fillRef>
+          <a:effectRef idx="2">
+            <a:schemeClr val="accent1"/>
+          </a:effectRef>
+          <a:fontRef idx="minor">
+            <a:schemeClr val="lt1"/>
+          </a:fontRef>
+        </p:style>
+        <p:txBody>
+          <a:bodyPr rtlCol="0" anchor="ctr"/>
+          <a:lstStyle/>
+          <a:p>
+            <a:pPr algn="ctr"/>
+          </a:p>
+        </p:txBody>
+      </p:sp>
+      <p:sp>
+        <p:nvSpPr>
+          <p:cNvPr id="4" name="TextBox 3"/>
+          <p:cNvSpPr txBox="1"/>
+          <p:nvPr/>
+        </p:nvSpPr>
+        <p:spPr>
+          <a:xfrm>
+            <a:off x="365760" y="27432"/>
+            <a:ext cx="7315200" cy="502920"/>
+          </a:xfrm>
+          <a:prstGeom prst="rect">
+            <a:avLst/>
+          </a:prstGeom>
+          <a:noFill/>
+        </p:spPr>
+        <p:txBody>
+          <a:bodyPr wrap="square" anchor="ctr">
+            <a:spAutoFit/>
+          </a:bodyPr>
+          <a:lstStyle/>
+          <a:p>
+            <a:pPr algn="l">
+              <a:lnSpc>
+                <a:spcPct val="100000"/>
+              </a:lnSpc>
+            </a:pPr>
+            <a:r>
+              <a:rPr sz="1500" b="1">
+                <a:solidFill>
+                  <a:srgbClr val="FFFFFF"/>
+                </a:solidFill>
+                <a:latin typeface="Malgun Gothic"/>
+              </a:rPr>
+              <a:t>🎒 Mangoi Student User Guide</a:t>
+            </a:r>
+          </a:p>
+        </p:txBody>
+      </p:sp>
+      <p:sp>
+        <p:nvSpPr>
+          <p:cNvPr id="5" name="TextBox 4"/>
+          <p:cNvSpPr txBox="1"/>
+          <p:nvPr/>
+        </p:nvSpPr>
+        <p:spPr>
+          <a:xfrm>
+            <a:off x="8168335" y="27432"/>
+            <a:ext cx="3657600" cy="502920"/>
+          </a:xfrm>
+          <a:prstGeom prst="rect">
+            <a:avLst/>
+          </a:prstGeom>
+          <a:noFill/>
+        </p:spPr>
+        <p:txBody>
+          <a:bodyPr wrap="square" anchor="ctr">
+            <a:spAutoFit/>
+          </a:bodyPr>
+          <a:lstStyle/>
+          <a:p>
+            <a:pPr algn="r">
+              <a:lnSpc>
+                <a:spcPct val="100000"/>
+              </a:lnSpc>
+            </a:pPr>
+            <a:r>
+              <a:rPr sz="1300" b="1">
+                <a:solidFill>
+                  <a:srgbClr val="F1F5F9"/>
+                </a:solidFill>
+                <a:latin typeface="Malgun Gothic"/>
+              </a:rPr>
+              <a:t>How to Use the Main Features</a:t>
+            </a:r>
+          </a:p>
+        </p:txBody>
+      </p:sp>
+      <p:sp>
+        <p:nvSpPr>
+          <p:cNvPr id="6" name="Rounded Rectangle 5"/>
+          <p:cNvSpPr/>
+          <p:nvPr/>
+        </p:nvSpPr>
+        <p:spPr>
+          <a:xfrm>
+            <a:off x="365760" y="822960"/>
+            <a:ext cx="868680" cy="868680"/>
+          </a:xfrm>
+          <a:prstGeom prst="roundRect">
+            <a:avLst/>
+          </a:prstGeom>
+          <a:solidFill>
+            <a:srgbClr val="7C3AED"/>
+          </a:solidFill>
+          <a:ln>
+            <a:noFill/>
+          </a:ln>
+          <a:effectLst/>
+        </p:spPr>
+        <p:style>
+          <a:lnRef idx="1">
+            <a:schemeClr val="accent1"/>
+          </a:lnRef>
+          <a:fillRef idx="3">
+            <a:schemeClr val="accent1"/>
+          </a:fillRef>
+          <a:effectRef idx="2">
+            <a:schemeClr val="accent1"/>
+          </a:effectRef>
+          <a:fontRef idx="minor">
+            <a:schemeClr val="lt1"/>
+          </a:fontRef>
+        </p:style>
+        <p:txBody>
+          <a:bodyPr rtlCol="0" anchor="ctr"/>
+          <a:lstStyle/>
+          <a:p>
+            <a:pPr algn="ctr"/>
+          </a:p>
+        </p:txBody>
+      </p:sp>
+      <p:sp>
+        <p:nvSpPr>
+          <p:cNvPr id="7" name="TextBox 6"/>
+          <p:cNvSpPr txBox="1"/>
+          <p:nvPr/>
+        </p:nvSpPr>
+        <p:spPr>
+          <a:xfrm>
+            <a:off x="365760" y="822960"/>
+            <a:ext cx="868680" cy="868680"/>
+          </a:xfrm>
+          <a:prstGeom prst="rect">
+            <a:avLst/>
+          </a:prstGeom>
+          <a:noFill/>
+        </p:spPr>
+        <p:txBody>
+          <a:bodyPr wrap="square" anchor="ctr">
+            <a:spAutoFit/>
+          </a:bodyPr>
+          <a:lstStyle/>
+          <a:p>
+            <a:pPr algn="ctr">
+              <a:lnSpc>
+                <a:spcPct val="100000"/>
+              </a:lnSpc>
+            </a:pPr>
+            <a:r>
+              <a:rPr sz="2600" b="1">
+                <a:solidFill>
+                  <a:srgbClr val="FFFFFF"/>
+                </a:solidFill>
+                <a:latin typeface="Malgun Gothic"/>
+              </a:rPr>
+              <a:t>39</a:t>
+            </a:r>
+          </a:p>
+        </p:txBody>
+      </p:sp>
+      <p:sp>
+        <p:nvSpPr>
+          <p:cNvPr id="8" name="TextBox 7"/>
+          <p:cNvSpPr txBox="1"/>
+          <p:nvPr/>
+        </p:nvSpPr>
+        <p:spPr>
+          <a:xfrm>
+            <a:off x="1371600" y="822960"/>
+            <a:ext cx="10424160" cy="502920"/>
+          </a:xfrm>
+          <a:prstGeom prst="rect">
+            <a:avLst/>
+          </a:prstGeom>
+          <a:noFill/>
+        </p:spPr>
+        <p:txBody>
+          <a:bodyPr wrap="square" anchor="t">
+            <a:spAutoFit/>
+          </a:bodyPr>
+          <a:lstStyle/>
+          <a:p>
+            <a:pPr algn="l">
+              <a:lnSpc>
+                <a:spcPct val="100000"/>
+              </a:lnSpc>
+            </a:pPr>
+            <a:r>
+              <a:rPr sz="2300" b="1">
+                <a:solidFill>
+                  <a:srgbClr val="1E2340"/>
+                </a:solidFill>
+                <a:latin typeface="Malgun Gothic"/>
+              </a:rPr>
+              <a:t>🚀 Where to next? (Learning-flow guide)</a:t>
+            </a:r>
+          </a:p>
+        </p:txBody>
+      </p:sp>
+      <p:sp>
+        <p:nvSpPr>
+          <p:cNvPr id="9" name="TextBox 8"/>
+          <p:cNvSpPr txBox="1"/>
+          <p:nvPr/>
+        </p:nvSpPr>
+        <p:spPr>
+          <a:xfrm>
+            <a:off x="1417320" y="1353312"/>
+            <a:ext cx="10424160" cy="320040"/>
+          </a:xfrm>
+          <a:prstGeom prst="rect">
+            <a:avLst/>
+          </a:prstGeom>
+          <a:noFill/>
+        </p:spPr>
+        <p:txBody>
+          <a:bodyPr wrap="square" anchor="t">
+            <a:spAutoFit/>
+          </a:bodyPr>
+          <a:lstStyle/>
+          <a:p>
+            <a:pPr algn="l">
+              <a:lnSpc>
+                <a:spcPct val="100000"/>
+              </a:lnSpc>
+            </a:pPr>
+            <a:r>
+              <a:rPr sz="1300" b="0">
+                <a:solidFill>
+                  <a:srgbClr val="64748B"/>
+                </a:solidFill>
+                <a:latin typeface="Malgun Gothic"/>
+              </a:rPr>
+              <a:t>Finish one activity and get the next one suggested</a:t>
+            </a:r>
+          </a:p>
+        </p:txBody>
+      </p:sp>
+      <p:sp>
+        <p:nvSpPr>
+          <p:cNvPr id="10" name="Rounded Rectangle 9"/>
+          <p:cNvSpPr/>
+          <p:nvPr/>
+        </p:nvSpPr>
+        <p:spPr>
+          <a:xfrm>
+            <a:off x="365760" y="1828800"/>
+            <a:ext cx="11430000" cy="777240"/>
+          </a:xfrm>
+          <a:prstGeom prst="roundRect">
+            <a:avLst/>
+          </a:prstGeom>
+          <a:solidFill>
+            <a:srgbClr val="F3F0FF"/>
+          </a:solidFill>
+          <a:ln>
+            <a:noFill/>
+          </a:ln>
+          <a:effectLst/>
+        </p:spPr>
+        <p:style>
+          <a:lnRef idx="1">
+            <a:schemeClr val="accent1"/>
+          </a:lnRef>
+          <a:fillRef idx="3">
+            <a:schemeClr val="accent1"/>
+          </a:fillRef>
+          <a:effectRef idx="2">
+            <a:schemeClr val="accent1"/>
+          </a:effectRef>
+          <a:fontRef idx="minor">
+            <a:schemeClr val="lt1"/>
+          </a:fontRef>
+        </p:style>
+        <p:txBody>
+          <a:bodyPr rtlCol="0" anchor="ctr"/>
+          <a:lstStyle/>
+          <a:p>
+            <a:pPr algn="ctr"/>
+          </a:p>
+        </p:txBody>
+      </p:sp>
+      <p:sp>
+        <p:nvSpPr>
+          <p:cNvPr id="11" name="TextBox 10"/>
+          <p:cNvSpPr txBox="1"/>
+          <p:nvPr/>
+        </p:nvSpPr>
+        <p:spPr>
+          <a:xfrm>
+            <a:off x="548640" y="1901952"/>
+            <a:ext cx="11064240" cy="640080"/>
+          </a:xfrm>
+          <a:prstGeom prst="rect">
+            <a:avLst/>
+          </a:prstGeom>
+          <a:noFill/>
+        </p:spPr>
+        <p:txBody>
+          <a:bodyPr wrap="square" anchor="t">
+            <a:spAutoFit/>
+          </a:bodyPr>
+          <a:lstStyle/>
+          <a:p>
+            <a:pPr algn="l">
+              <a:lnSpc>
+                <a:spcPct val="115000"/>
+              </a:lnSpc>
+            </a:pPr>
+            <a:r>
+              <a:rPr sz="1200" b="0">
+                <a:solidFill>
+                  <a:srgbClr val="334155"/>
+                </a:solidFill>
+                <a:latin typeface="Malgun Gothic"/>
+              </a:rPr>
+              <a:t>When you finish an activity — warm-up, game, class, review, pronunciation — a ‘🚀 Where would you like to go next?’ menu pops up. No need to hunt for menus again; just follow the recommended (⭐) item to flow into your next activity.</a:t>
+            </a:r>
+          </a:p>
+        </p:txBody>
+      </p:sp>
+      <p:sp>
+        <p:nvSpPr>
+          <p:cNvPr id="12" name="TextBox 11"/>
+          <p:cNvSpPr txBox="1"/>
+          <p:nvPr/>
+        </p:nvSpPr>
+        <p:spPr>
+          <a:xfrm>
+            <a:off x="457200" y="2743200"/>
+            <a:ext cx="5669280" cy="320040"/>
+          </a:xfrm>
+          <a:prstGeom prst="rect">
+            <a:avLst/>
+          </a:prstGeom>
+          <a:noFill/>
+        </p:spPr>
+        <p:txBody>
+          <a:bodyPr wrap="square" anchor="t">
+            <a:spAutoFit/>
+          </a:bodyPr>
+          <a:lstStyle/>
+          <a:p>
+            <a:pPr algn="l">
+              <a:lnSpc>
+                <a:spcPct val="100000"/>
+              </a:lnSpc>
+            </a:pPr>
+            <a:r>
+              <a:rPr sz="1350" b="1">
+                <a:solidFill>
+                  <a:srgbClr val="7C3AED"/>
+                </a:solidFill>
+                <a:latin typeface="Malgun Gothic"/>
+              </a:rPr>
+              <a:t>How to use</a:t>
+            </a:r>
+          </a:p>
+        </p:txBody>
+      </p:sp>
+      <p:sp>
+        <p:nvSpPr>
+          <p:cNvPr id="13" name="TextBox 12"/>
+          <p:cNvSpPr txBox="1"/>
+          <p:nvPr/>
+        </p:nvSpPr>
+        <p:spPr>
+          <a:xfrm>
+            <a:off x="457200" y="3108960"/>
+            <a:ext cx="5669280" cy="2377440"/>
+          </a:xfrm>
+          <a:prstGeom prst="rect">
+            <a:avLst/>
+          </a:prstGeom>
+          <a:noFill/>
+        </p:spPr>
+        <p:txBody>
+          <a:bodyPr wrap="square">
+            <a:spAutoFit/>
+          </a:bodyPr>
+          <a:lstStyle/>
+          <a:p>
+            <a:pPr>
+              <a:lnSpc>
+                <a:spcPct val="115000"/>
+              </a:lnSpc>
+              <a:spcAft>
+                <a:spcPts val="600"/>
+              </a:spcAft>
+            </a:pPr>
+            <a:r>
+              <a:rPr sz="1050" b="1">
+                <a:solidFill>
+                  <a:srgbClr val="7C3AED"/>
+                </a:solidFill>
+                <a:latin typeface="Malgun Gothic"/>
+              </a:rPr>
+              <a:t>● </a:t>
+            </a:r>
+            <a:r>
+              <a:rPr sz="1250">
+                <a:solidFill>
+                  <a:srgbClr val="334155"/>
+                </a:solidFill>
+                <a:latin typeface="Malgun Gothic"/>
+              </a:rPr>
+              <a:t>Fully complete a warm-up, student game, review quiz, class, or step-by-step pronunciation.</a:t>
+            </a:r>
+          </a:p>
+          <a:p>
+            <a:pPr>
+              <a:lnSpc>
+                <a:spcPct val="115000"/>
+              </a:lnSpc>
+              <a:spcAft>
+                <a:spcPts val="600"/>
+              </a:spcAft>
+            </a:pPr>
+            <a:r>
+              <a:rPr sz="1050" b="1">
+                <a:solidFill>
+                  <a:srgbClr val="7C3AED"/>
+                </a:solidFill>
+                <a:latin typeface="Malgun Gothic"/>
+              </a:rPr>
+              <a:t>● </a:t>
+            </a:r>
+            <a:r>
+              <a:rPr sz="1250">
+                <a:solidFill>
+                  <a:srgbClr val="334155"/>
+                </a:solidFill>
+                <a:latin typeface="Malgun Gothic"/>
+              </a:rPr>
+              <a:t>Look for the ‘🚀 Choose next activity’ button (or the menu that appears automatically).</a:t>
+            </a:r>
+          </a:p>
+          <a:p>
+            <a:pPr>
+              <a:lnSpc>
+                <a:spcPct val="115000"/>
+              </a:lnSpc>
+              <a:spcAft>
+                <a:spcPts val="600"/>
+              </a:spcAft>
+            </a:pPr>
+            <a:r>
+              <a:rPr sz="1050" b="1">
+                <a:solidFill>
+                  <a:srgbClr val="7C3AED"/>
+                </a:solidFill>
+                <a:latin typeface="Malgun Gothic"/>
+              </a:rPr>
+              <a:t>● </a:t>
+            </a:r>
+            <a:r>
+              <a:rPr sz="1250">
+                <a:solidFill>
+                  <a:srgbClr val="334155"/>
+                </a:solidFill>
+                <a:latin typeface="Malgun Gothic"/>
+              </a:rPr>
+              <a:t>Pick from Enter Class · AI Warm-up · Review Quiz · Student Games · Replay Recording · Pronunciation, etc.</a:t>
+            </a:r>
+          </a:p>
+          <a:p>
+            <a:pPr>
+              <a:lnSpc>
+                <a:spcPct val="115000"/>
+              </a:lnSpc>
+              <a:spcAft>
+                <a:spcPts val="600"/>
+              </a:spcAft>
+            </a:pPr>
+            <a:r>
+              <a:rPr sz="1050" b="1">
+                <a:solidFill>
+                  <a:srgbClr val="7C3AED"/>
+                </a:solidFill>
+                <a:latin typeface="Malgun Gothic"/>
+              </a:rPr>
+              <a:t>● </a:t>
+            </a:r>
+            <a:r>
+              <a:rPr sz="1250">
+                <a:solidFill>
+                  <a:srgbClr val="334155"/>
+                </a:solidFill>
+                <a:latin typeface="Malgun Gothic"/>
+              </a:rPr>
+              <a:t>The recommended (⭐) item is a good next step for right now.</a:t>
+            </a:r>
+          </a:p>
+        </p:txBody>
+      </p:sp>
+      <p:sp>
+        <p:nvSpPr>
+          <p:cNvPr id="14" name="Rounded Rectangle 13"/>
+          <p:cNvSpPr/>
+          <p:nvPr/>
+        </p:nvSpPr>
+        <p:spPr>
+          <a:xfrm>
+            <a:off x="457200" y="4782312"/>
+            <a:ext cx="5669280" cy="1316736"/>
+          </a:xfrm>
+          <a:prstGeom prst="roundRect">
+            <a:avLst/>
+          </a:prstGeom>
+          <a:solidFill>
+            <a:srgbClr val="F4F7FF"/>
+          </a:solidFill>
+          <a:ln w="12700">
+            <a:solidFill>
+              <a:srgbClr val="7C3AED"/>
+            </a:solidFill>
+          </a:ln>
+          <a:effectLst/>
+        </p:spPr>
+        <p:style>
+          <a:lnRef idx="1">
+            <a:schemeClr val="accent1"/>
+          </a:lnRef>
+          <a:fillRef idx="3">
+            <a:schemeClr val="accent1"/>
+          </a:fillRef>
+          <a:effectRef idx="2">
+            <a:schemeClr val="accent1"/>
+          </a:effectRef>
+          <a:fontRef idx="minor">
+            <a:schemeClr val="lt1"/>
+          </a:fontRef>
+        </p:style>
+        <p:txBody>
+          <a:bodyPr rtlCol="0" anchor="ctr"/>
+          <a:lstStyle/>
+          <a:p>
+            <a:pPr algn="ctr"/>
+          </a:p>
+        </p:txBody>
+      </p:sp>
+      <p:sp>
+        <p:nvSpPr>
+          <p:cNvPr id="15" name="TextBox 14"/>
+          <p:cNvSpPr txBox="1"/>
+          <p:nvPr/>
+        </p:nvSpPr>
+        <p:spPr>
+          <a:xfrm>
+            <a:off x="594360" y="4837175"/>
+            <a:ext cx="5394960" cy="274320"/>
+          </a:xfrm>
+          <a:prstGeom prst="rect">
+            <a:avLst/>
+          </a:prstGeom>
+          <a:noFill/>
+        </p:spPr>
+        <p:txBody>
+          <a:bodyPr wrap="square" anchor="t">
+            <a:spAutoFit/>
+          </a:bodyPr>
+          <a:lstStyle/>
+          <a:p>
+            <a:pPr algn="l">
+              <a:lnSpc>
+                <a:spcPct val="100000"/>
+              </a:lnSpc>
+            </a:pPr>
+            <a:r>
+              <a:rPr sz="1150" b="1">
+                <a:solidFill>
+                  <a:srgbClr val="7C3AED"/>
+                </a:solidFill>
+                <a:latin typeface="Malgun Gothic"/>
+              </a:rPr>
+              <a:t>✅ Key Points</a:t>
+            </a:r>
+          </a:p>
+        </p:txBody>
+      </p:sp>
+      <p:sp>
+        <p:nvSpPr>
+          <p:cNvPr id="16" name="TextBox 15"/>
+          <p:cNvSpPr txBox="1"/>
+          <p:nvPr/>
+        </p:nvSpPr>
+        <p:spPr>
+          <a:xfrm>
+            <a:off x="594360" y="5111496"/>
+            <a:ext cx="5394960" cy="950976"/>
+          </a:xfrm>
+          <a:prstGeom prst="rect">
+            <a:avLst/>
+          </a:prstGeom>
+          <a:noFill/>
+        </p:spPr>
+        <p:txBody>
+          <a:bodyPr wrap="square">
+            <a:spAutoFit/>
+          </a:bodyPr>
+          <a:lstStyle/>
+          <a:p>
+            <a:pPr>
+              <a:lnSpc>
+                <a:spcPct val="115000"/>
+              </a:lnSpc>
+              <a:spcAft>
+                <a:spcPts val="200"/>
+              </a:spcAft>
+            </a:pPr>
+            <a:r>
+              <a:rPr sz="900" b="1">
+                <a:solidFill>
+                  <a:srgbClr val="7C3AED"/>
+                </a:solidFill>
+                <a:latin typeface="Malgun Gothic"/>
+              </a:rPr>
+              <a:t>● </a:t>
+            </a:r>
+            <a:r>
+              <a:rPr sz="1100">
+                <a:solidFill>
+                  <a:srgbClr val="334155"/>
+                </a:solidFill>
+                <a:latin typeface="Malgun Gothic"/>
+              </a:rPr>
+              <a:t>Suggested flow: Warm-up → Game → Class → Review → Pronunciation → Game, naturally connected.</a:t>
+            </a:r>
+          </a:p>
+          <a:p>
+            <a:pPr>
+              <a:lnSpc>
+                <a:spcPct val="115000"/>
+              </a:lnSpc>
+              <a:spcAft>
+                <a:spcPts val="200"/>
+              </a:spcAft>
+            </a:pPr>
+            <a:r>
+              <a:rPr sz="900" b="1">
+                <a:solidFill>
+                  <a:srgbClr val="7C3AED"/>
+                </a:solidFill>
+                <a:latin typeface="Malgun Gothic"/>
+              </a:rPr>
+              <a:t>● </a:t>
+            </a:r>
+            <a:r>
+              <a:rPr sz="1100">
+                <a:solidFill>
+                  <a:srgbClr val="334155"/>
+                </a:solidFill>
+                <a:latin typeface="Malgun Gothic"/>
+              </a:rPr>
+              <a:t>Choosing ‘Replay Recording’ instantly replays your last class video.</a:t>
+            </a:r>
+          </a:p>
+          <a:p>
+            <a:pPr>
+              <a:lnSpc>
+                <a:spcPct val="115000"/>
+              </a:lnSpc>
+              <a:spcAft>
+                <a:spcPts val="200"/>
+              </a:spcAft>
+            </a:pPr>
+            <a:r>
+              <a:rPr sz="900" b="1">
+                <a:solidFill>
+                  <a:srgbClr val="7C3AED"/>
+                </a:solidFill>
+                <a:latin typeface="Malgun Gothic"/>
+              </a:rPr>
+              <a:t>● </a:t>
+            </a:r>
+            <a:r>
+              <a:rPr sz="1100">
+                <a:solidFill>
+                  <a:srgbClr val="334155"/>
+                </a:solidFill>
+                <a:latin typeface="Malgun Gothic"/>
+              </a:rPr>
+              <a:t>Even without playing a game/quiz, the list screen's ‘🚀 Go next’ button opens the menu.</a:t>
+            </a:r>
+          </a:p>
+        </p:txBody>
+      </p:sp>
+      <p:sp>
+        <p:nvSpPr>
+          <p:cNvPr id="17" name="Rounded Rectangle 16"/>
+          <p:cNvSpPr/>
+          <p:nvPr/>
+        </p:nvSpPr>
+        <p:spPr>
+          <a:xfrm>
+            <a:off x="457200" y="6208775"/>
+            <a:ext cx="5669280" cy="658368"/>
+          </a:xfrm>
+          <a:prstGeom prst="roundRect">
+            <a:avLst/>
+          </a:prstGeom>
+          <a:solidFill>
+            <a:srgbClr val="FFF7E6"/>
+          </a:solidFill>
+          <a:ln w="12700">
+            <a:solidFill>
+              <a:srgbClr val="FF9F1C"/>
+            </a:solidFill>
+          </a:ln>
+          <a:effectLst/>
+        </p:spPr>
+        <p:style>
+          <a:lnRef idx="1">
+            <a:schemeClr val="accent1"/>
+          </a:lnRef>
+          <a:fillRef idx="3">
+            <a:schemeClr val="accent1"/>
+          </a:fillRef>
+          <a:effectRef idx="2">
+            <a:schemeClr val="accent1"/>
+          </a:effectRef>
+          <a:fontRef idx="minor">
+            <a:schemeClr val="lt1"/>
+          </a:fontRef>
+        </p:style>
+        <p:txBody>
+          <a:bodyPr rtlCol="0" anchor="ctr"/>
+          <a:lstStyle/>
+          <a:p>
+            <a:pPr algn="ctr"/>
+          </a:p>
+        </p:txBody>
+      </p:sp>
+      <p:sp>
+        <p:nvSpPr>
+          <p:cNvPr id="18" name="TextBox 17"/>
+          <p:cNvSpPr txBox="1"/>
+          <p:nvPr/>
+        </p:nvSpPr>
+        <p:spPr>
+          <a:xfrm>
+            <a:off x="594360" y="6254495"/>
+            <a:ext cx="5394960" cy="566928"/>
+          </a:xfrm>
+          <a:prstGeom prst="rect">
+            <a:avLst/>
+          </a:prstGeom>
+          <a:noFill/>
+        </p:spPr>
+        <p:txBody>
+          <a:bodyPr wrap="square" anchor="t">
+            <a:spAutoFit/>
+          </a:bodyPr>
+          <a:lstStyle/>
+          <a:p>
+            <a:pPr algn="l">
+              <a:lnSpc>
+                <a:spcPct val="105000"/>
+              </a:lnSpc>
+            </a:pPr>
+            <a:r>
+              <a:rPr sz="1050" b="0">
+                <a:solidFill>
+                  <a:srgbClr val="5B4A2A"/>
+                </a:solidFill>
+                <a:latin typeface="Malgun Gothic"/>
+              </a:rPr>
+              <a:t>💡 Tip · When you're unsure what to do, open this menu to keep today's study flowing smoothly.</a:t>
+            </a:r>
+          </a:p>
+        </p:txBody>
+      </p:sp>
+      <p:sp>
+        <p:nvSpPr>
+          <p:cNvPr id="19" name="Rectangle 18"/>
+          <p:cNvSpPr/>
+          <p:nvPr/>
+        </p:nvSpPr>
+        <p:spPr>
+          <a:xfrm>
+            <a:off x="6300216" y="2345436"/>
+            <a:ext cx="5596128" cy="3538728"/>
+          </a:xfrm>
+          <a:prstGeom prst="rect">
+            <a:avLst/>
+          </a:prstGeom>
+          <a:solidFill>
+            <a:srgbClr val="FFFFFF"/>
+          </a:solidFill>
+          <a:ln w="12700">
+            <a:solidFill>
+              <a:srgbClr val="E2E8F0"/>
+            </a:solidFill>
+          </a:ln>
+          <a:effectLst/>
+        </p:spPr>
+        <p:style>
+          <a:lnRef idx="1">
+            <a:schemeClr val="accent1"/>
+          </a:lnRef>
+          <a:fillRef idx="3">
+            <a:schemeClr val="accent1"/>
+          </a:fillRef>
+          <a:effectRef idx="2">
+            <a:schemeClr val="accent1"/>
+          </a:effectRef>
+          <a:fontRef idx="minor">
+            <a:schemeClr val="lt1"/>
+          </a:fontRef>
+        </p:style>
+        <p:txBody>
+          <a:bodyPr rtlCol="0" anchor="ctr"/>
+          <a:lstStyle/>
+          <a:p>
+            <a:pPr algn="ctr"/>
+          </a:p>
+        </p:txBody>
+      </p:sp>
+      <p:pic>
+        <p:nvPicPr>
+          <p:cNvPr id="20" name="Picture 19" descr="student_flow.jpg"/>
+          <p:cNvPicPr>
+            <a:picLocks noChangeAspect="1"/>
+          </p:cNvPicPr>
+          <p:nvPr/>
+        </p:nvPicPr>
+        <p:blipFill>
+          <a:blip r:embed="rId2"/>
+          <a:stretch>
+            <a:fillRect/>
+          </a:stretch>
+        </p:blipFill>
+        <p:spPr>
+          <a:xfrm>
+            <a:off x="6355080" y="2400300"/>
+            <a:ext cx="5486400" cy="3429000"/>
+          </a:xfrm>
+          <a:prstGeom prst="rect">
+            <a:avLst/>
+          </a:prstGeom>
+        </p:spPr>
+      </p:pic>
+    </p:spTree>
+  </p:cSld>
+  <p:clrMapOvr>
+    <a:masterClrMapping/>
+  </p:clrMapOvr>
+</p:sld>
+</file>
+
+<file path=ppt/slides/slide42.xml><?xml version="1.0" encoding="utf-8"?>
+<p:sld xmlns:a="http://schemas.openxmlformats.org/drawingml/2006/main" xmlns:p="http://schemas.openxmlformats.org/presentationml/2006/main" xmlns:r="http://schemas.openxmlformats.org/officeDocument/2006/relationships">
+  <p:cSld>
+    <p:bg>
+      <p:bgPr>
+        <a:solidFill>
+          <a:srgbClr val="FFFFFF"/>
+        </a:solidFill>
+        <a:effectLst/>
+      </p:bgPr>
+    </p:bg>
+    <p:spTree>
+      <p:nvGrpSpPr>
+        <p:cNvPr id="1" name=""/>
+        <p:cNvGrpSpPr/>
+        <p:nvPr/>
+      </p:nvGrpSpPr>
+      <p:grpSpPr/>
+      <p:sp>
+        <p:nvSpPr>
+          <p:cNvPr id="2" name="Rectangle 1"/>
+          <p:cNvSpPr/>
+          <p:nvPr/>
+        </p:nvSpPr>
+        <p:spPr>
+          <a:xfrm>
+            <a:off x="0" y="0"/>
+            <a:ext cx="12191695" cy="566928"/>
+          </a:xfrm>
+          <a:prstGeom prst="rect">
+            <a:avLst/>
+          </a:prstGeom>
+          <a:solidFill>
+            <a:srgbClr val="7C3AED"/>
+          </a:solidFill>
+          <a:ln>
+            <a:noFill/>
+          </a:ln>
+          <a:effectLst/>
+        </p:spPr>
+        <p:style>
+          <a:lnRef idx="1">
+            <a:schemeClr val="accent1"/>
+          </a:lnRef>
+          <a:fillRef idx="3">
+            <a:schemeClr val="accent1"/>
+          </a:fillRef>
+          <a:effectRef idx="2">
+            <a:schemeClr val="accent1"/>
+          </a:effectRef>
+          <a:fontRef idx="minor">
+            <a:schemeClr val="lt1"/>
+          </a:fontRef>
+        </p:style>
+        <p:txBody>
+          <a:bodyPr rtlCol="0" anchor="ctr"/>
+          <a:lstStyle/>
+          <a:p>
+            <a:pPr algn="ctr"/>
+          </a:p>
+        </p:txBody>
+      </p:sp>
+      <p:sp>
+        <p:nvSpPr>
+          <p:cNvPr id="3" name="Rectangle 2"/>
+          <p:cNvSpPr/>
+          <p:nvPr/>
+        </p:nvSpPr>
+        <p:spPr>
+          <a:xfrm>
+            <a:off x="0" y="566928"/>
+            <a:ext cx="12191695" cy="54864"/>
+          </a:xfrm>
+          <a:prstGeom prst="rect">
+            <a:avLst/>
+          </a:prstGeom>
+          <a:solidFill>
+            <a:srgbClr val="FF9F1C"/>
+          </a:solidFill>
+          <a:ln>
+            <a:noFill/>
+          </a:ln>
+          <a:effectLst/>
+        </p:spPr>
+        <p:style>
+          <a:lnRef idx="1">
+            <a:schemeClr val="accent1"/>
+          </a:lnRef>
+          <a:fillRef idx="3">
+            <a:schemeClr val="accent1"/>
+          </a:fillRef>
+          <a:effectRef idx="2">
+            <a:schemeClr val="accent1"/>
+          </a:effectRef>
+          <a:fontRef idx="minor">
+            <a:schemeClr val="lt1"/>
+          </a:fontRef>
+        </p:style>
+        <p:txBody>
+          <a:bodyPr rtlCol="0" anchor="ctr"/>
+          <a:lstStyle/>
+          <a:p>
+            <a:pPr algn="ctr"/>
+          </a:p>
+        </p:txBody>
+      </p:sp>
+      <p:sp>
+        <p:nvSpPr>
+          <p:cNvPr id="4" name="TextBox 3"/>
+          <p:cNvSpPr txBox="1"/>
+          <p:nvPr/>
+        </p:nvSpPr>
+        <p:spPr>
+          <a:xfrm>
+            <a:off x="365760" y="27432"/>
+            <a:ext cx="7315200" cy="502920"/>
+          </a:xfrm>
+          <a:prstGeom prst="rect">
+            <a:avLst/>
+          </a:prstGeom>
+          <a:noFill/>
+        </p:spPr>
+        <p:txBody>
+          <a:bodyPr wrap="square" anchor="ctr">
+            <a:spAutoFit/>
+          </a:bodyPr>
+          <a:lstStyle/>
+          <a:p>
+            <a:pPr algn="l">
+              <a:lnSpc>
+                <a:spcPct val="100000"/>
+              </a:lnSpc>
+            </a:pPr>
+            <a:r>
+              <a:rPr sz="1500" b="1">
+                <a:solidFill>
+                  <a:srgbClr val="FFFFFF"/>
+                </a:solidFill>
+                <a:latin typeface="Malgun Gothic"/>
+              </a:rPr>
+              <a:t>🎒 Mangoi Student User Guide</a:t>
+            </a:r>
+          </a:p>
+        </p:txBody>
+      </p:sp>
+      <p:sp>
+        <p:nvSpPr>
+          <p:cNvPr id="5" name="TextBox 4"/>
+          <p:cNvSpPr txBox="1"/>
+          <p:nvPr/>
+        </p:nvSpPr>
+        <p:spPr>
+          <a:xfrm>
+            <a:off x="8168335" y="27432"/>
+            <a:ext cx="3657600" cy="502920"/>
+          </a:xfrm>
+          <a:prstGeom prst="rect">
+            <a:avLst/>
+          </a:prstGeom>
+          <a:noFill/>
+        </p:spPr>
+        <p:txBody>
+          <a:bodyPr wrap="square" anchor="ctr">
+            <a:spAutoFit/>
+          </a:bodyPr>
+          <a:lstStyle/>
+          <a:p>
+            <a:pPr algn="r">
+              <a:lnSpc>
+                <a:spcPct val="100000"/>
+              </a:lnSpc>
+            </a:pPr>
+            <a:r>
+              <a:rPr sz="1300" b="1">
+                <a:solidFill>
+                  <a:srgbClr val="F1F5F9"/>
+                </a:solidFill>
+                <a:latin typeface="Malgun Gothic"/>
+              </a:rPr>
+              <a:t>How to Use the Main Features</a:t>
+            </a:r>
+          </a:p>
+        </p:txBody>
+      </p:sp>
+      <p:sp>
+        <p:nvSpPr>
+          <p:cNvPr id="6" name="Rounded Rectangle 5"/>
+          <p:cNvSpPr/>
+          <p:nvPr/>
+        </p:nvSpPr>
+        <p:spPr>
+          <a:xfrm>
+            <a:off x="365760" y="822960"/>
+            <a:ext cx="868680" cy="868680"/>
+          </a:xfrm>
+          <a:prstGeom prst="roundRect">
+            <a:avLst/>
+          </a:prstGeom>
+          <a:solidFill>
+            <a:srgbClr val="7C3AED"/>
+          </a:solidFill>
+          <a:ln>
+            <a:noFill/>
+          </a:ln>
+          <a:effectLst/>
+        </p:spPr>
+        <p:style>
+          <a:lnRef idx="1">
+            <a:schemeClr val="accent1"/>
+          </a:lnRef>
+          <a:fillRef idx="3">
+            <a:schemeClr val="accent1"/>
+          </a:fillRef>
+          <a:effectRef idx="2">
+            <a:schemeClr val="accent1"/>
+          </a:effectRef>
+          <a:fontRef idx="minor">
+            <a:schemeClr val="lt1"/>
+          </a:fontRef>
+        </p:style>
+        <p:txBody>
+          <a:bodyPr rtlCol="0" anchor="ctr"/>
+          <a:lstStyle/>
+          <a:p>
+            <a:pPr algn="ctr"/>
+          </a:p>
+        </p:txBody>
+      </p:sp>
+      <p:sp>
+        <p:nvSpPr>
+          <p:cNvPr id="7" name="TextBox 6"/>
+          <p:cNvSpPr txBox="1"/>
+          <p:nvPr/>
+        </p:nvSpPr>
+        <p:spPr>
+          <a:xfrm>
+            <a:off x="365760" y="822960"/>
+            <a:ext cx="868680" cy="868680"/>
+          </a:xfrm>
+          <a:prstGeom prst="rect">
+            <a:avLst/>
+          </a:prstGeom>
+          <a:noFill/>
+        </p:spPr>
+        <p:txBody>
+          <a:bodyPr wrap="square" anchor="ctr">
+            <a:spAutoFit/>
+          </a:bodyPr>
+          <a:lstStyle/>
+          <a:p>
+            <a:pPr algn="ctr">
+              <a:lnSpc>
+                <a:spcPct val="100000"/>
+              </a:lnSpc>
+            </a:pPr>
+            <a:r>
+              <a:rPr sz="2600" b="1">
+                <a:solidFill>
+                  <a:srgbClr val="FFFFFF"/>
+                </a:solidFill>
+                <a:latin typeface="Malgun Gothic"/>
+              </a:rPr>
+              <a:t>40</a:t>
+            </a:r>
+          </a:p>
+        </p:txBody>
+      </p:sp>
+      <p:sp>
+        <p:nvSpPr>
+          <p:cNvPr id="8" name="TextBox 7"/>
+          <p:cNvSpPr txBox="1"/>
+          <p:nvPr/>
+        </p:nvSpPr>
+        <p:spPr>
+          <a:xfrm>
+            <a:off x="1371600" y="822960"/>
+            <a:ext cx="10424160" cy="502920"/>
+          </a:xfrm>
+          <a:prstGeom prst="rect">
+            <a:avLst/>
+          </a:prstGeom>
+          <a:noFill/>
+        </p:spPr>
+        <p:txBody>
+          <a:bodyPr wrap="square" anchor="t">
+            <a:spAutoFit/>
+          </a:bodyPr>
+          <a:lstStyle/>
+          <a:p>
+            <a:pPr algn="l">
+              <a:lnSpc>
+                <a:spcPct val="100000"/>
+              </a:lnSpc>
+            </a:pPr>
+            <a:r>
+              <a:rPr sz="2300" b="1">
+                <a:solidFill>
+                  <a:srgbClr val="1E2340"/>
+                </a:solidFill>
+                <a:latin typeface="Malgun Gothic"/>
+              </a:rPr>
+              <a:t>🤖 Ask the A.i Assistant</a:t>
+            </a:r>
+          </a:p>
+        </p:txBody>
+      </p:sp>
+      <p:sp>
+        <p:nvSpPr>
+          <p:cNvPr id="9" name="TextBox 8"/>
+          <p:cNvSpPr txBox="1"/>
+          <p:nvPr/>
+        </p:nvSpPr>
+        <p:spPr>
+          <a:xfrm>
+            <a:off x="1417320" y="1353312"/>
+            <a:ext cx="10424160" cy="320040"/>
+          </a:xfrm>
+          <a:prstGeom prst="rect">
+            <a:avLst/>
+          </a:prstGeom>
+          <a:noFill/>
+        </p:spPr>
+        <p:txBody>
+          <a:bodyPr wrap="square" anchor="t">
+            <a:spAutoFit/>
+          </a:bodyPr>
+          <a:lstStyle/>
+          <a:p>
+            <a:pPr algn="l">
+              <a:lnSpc>
+                <a:spcPct val="100000"/>
+              </a:lnSpc>
+            </a:pPr>
+            <a:r>
+              <a:rPr sz="1300" b="0">
+                <a:solidFill>
+                  <a:srgbClr val="64748B"/>
+                </a:solidFill>
+                <a:latin typeface="Malgun Gothic"/>
+              </a:rPr>
+              <a:t>The consultant avatar at the bottom-right</a:t>
+            </a:r>
+          </a:p>
+        </p:txBody>
+      </p:sp>
+      <p:sp>
+        <p:nvSpPr>
+          <p:cNvPr id="10" name="Rounded Rectangle 9"/>
+          <p:cNvSpPr/>
+          <p:nvPr/>
+        </p:nvSpPr>
+        <p:spPr>
+          <a:xfrm>
+            <a:off x="365760" y="1828800"/>
+            <a:ext cx="11430000" cy="777240"/>
+          </a:xfrm>
+          <a:prstGeom prst="roundRect">
+            <a:avLst/>
+          </a:prstGeom>
+          <a:solidFill>
+            <a:srgbClr val="F3F0FF"/>
+          </a:solidFill>
+          <a:ln>
+            <a:noFill/>
+          </a:ln>
+          <a:effectLst/>
+        </p:spPr>
+        <p:style>
+          <a:lnRef idx="1">
+            <a:schemeClr val="accent1"/>
+          </a:lnRef>
+          <a:fillRef idx="3">
+            <a:schemeClr val="accent1"/>
+          </a:fillRef>
+          <a:effectRef idx="2">
+            <a:schemeClr val="accent1"/>
+          </a:effectRef>
+          <a:fontRef idx="minor">
+            <a:schemeClr val="lt1"/>
+          </a:fontRef>
+        </p:style>
+        <p:txBody>
+          <a:bodyPr rtlCol="0" anchor="ctr"/>
+          <a:lstStyle/>
+          <a:p>
+            <a:pPr algn="ctr"/>
+          </a:p>
+        </p:txBody>
+      </p:sp>
+      <p:sp>
+        <p:nvSpPr>
+          <p:cNvPr id="11" name="TextBox 10"/>
+          <p:cNvSpPr txBox="1"/>
+          <p:nvPr/>
+        </p:nvSpPr>
+        <p:spPr>
+          <a:xfrm>
+            <a:off x="548640" y="1901952"/>
+            <a:ext cx="11064240" cy="640080"/>
+          </a:xfrm>
+          <a:prstGeom prst="rect">
+            <a:avLst/>
+          </a:prstGeom>
+          <a:noFill/>
+        </p:spPr>
+        <p:txBody>
+          <a:bodyPr wrap="square" anchor="t">
+            <a:spAutoFit/>
+          </a:bodyPr>
+          <a:lstStyle/>
+          <a:p>
+            <a:pPr algn="l">
+              <a:lnSpc>
+                <a:spcPct val="115000"/>
+              </a:lnSpc>
+            </a:pPr>
+            <a:r>
+              <a:rPr sz="1200" b="0">
+                <a:solidFill>
+                  <a:srgbClr val="334155"/>
+                </a:solidFill>
+                <a:latin typeface="Malgun Gothic"/>
+              </a:rPr>
+              <a:t>Tap the ‘A.i Assistant’ at the bottom-right of the screen to ask anything, anytime. It explains how to use features and where they are, and can take you straight to the right menu.</a:t>
+            </a:r>
+          </a:p>
+        </p:txBody>
+      </p:sp>
+      <p:sp>
+        <p:nvSpPr>
+          <p:cNvPr id="12" name="TextBox 11"/>
+          <p:cNvSpPr txBox="1"/>
+          <p:nvPr/>
+        </p:nvSpPr>
+        <p:spPr>
+          <a:xfrm>
+            <a:off x="457200" y="2743200"/>
+            <a:ext cx="5669280" cy="320040"/>
+          </a:xfrm>
+          <a:prstGeom prst="rect">
+            <a:avLst/>
+          </a:prstGeom>
+          <a:noFill/>
+        </p:spPr>
+        <p:txBody>
+          <a:bodyPr wrap="square" anchor="t">
+            <a:spAutoFit/>
+          </a:bodyPr>
+          <a:lstStyle/>
+          <a:p>
+            <a:pPr algn="l">
+              <a:lnSpc>
+                <a:spcPct val="100000"/>
+              </a:lnSpc>
+            </a:pPr>
+            <a:r>
+              <a:rPr sz="1350" b="1">
+                <a:solidFill>
+                  <a:srgbClr val="7C3AED"/>
+                </a:solidFill>
+                <a:latin typeface="Malgun Gothic"/>
+              </a:rPr>
+              <a:t>How to use</a:t>
+            </a:r>
+          </a:p>
+        </p:txBody>
+      </p:sp>
+      <p:sp>
+        <p:nvSpPr>
+          <p:cNvPr id="13" name="TextBox 12"/>
+          <p:cNvSpPr txBox="1"/>
+          <p:nvPr/>
+        </p:nvSpPr>
+        <p:spPr>
+          <a:xfrm>
+            <a:off x="457200" y="3108960"/>
+            <a:ext cx="5669280" cy="2377440"/>
+          </a:xfrm>
+          <a:prstGeom prst="rect">
+            <a:avLst/>
+          </a:prstGeom>
+          <a:noFill/>
+        </p:spPr>
+        <p:txBody>
+          <a:bodyPr wrap="square">
+            <a:spAutoFit/>
+          </a:bodyPr>
+          <a:lstStyle/>
+          <a:p>
+            <a:pPr>
+              <a:lnSpc>
+                <a:spcPct val="115000"/>
+              </a:lnSpc>
+              <a:spcAft>
+                <a:spcPts val="600"/>
+              </a:spcAft>
+            </a:pPr>
+            <a:r>
+              <a:rPr sz="1050" b="1">
+                <a:solidFill>
+                  <a:srgbClr val="7C3AED"/>
+                </a:solidFill>
+                <a:latin typeface="Malgun Gothic"/>
+              </a:rPr>
+              <a:t>● </a:t>
+            </a:r>
+            <a:r>
+              <a:rPr sz="1250">
+                <a:solidFill>
+                  <a:srgbClr val="334155"/>
+                </a:solidFill>
+                <a:latin typeface="Malgun Gothic"/>
+              </a:rPr>
+              <a:t>Tap the A.i Assistant icon at the bottom-right of the home screen.</a:t>
+            </a:r>
+          </a:p>
+          <a:p>
+            <a:pPr>
+              <a:lnSpc>
+                <a:spcPct val="115000"/>
+              </a:lnSpc>
+              <a:spcAft>
+                <a:spcPts val="600"/>
+              </a:spcAft>
+            </a:pPr>
+            <a:r>
+              <a:rPr sz="1050" b="1">
+                <a:solidFill>
+                  <a:srgbClr val="7C3AED"/>
+                </a:solidFill>
+                <a:latin typeface="Malgun Gothic"/>
+              </a:rPr>
+              <a:t>● </a:t>
+            </a:r>
+            <a:r>
+              <a:rPr sz="1250">
+                <a:solidFill>
+                  <a:srgbClr val="334155"/>
+                </a:solidFill>
+                <a:latin typeface="Malgun Gothic"/>
+              </a:rPr>
+              <a:t>Type your question freely (e.g. “Where do I take the review quiz?”).</a:t>
+            </a:r>
+          </a:p>
+          <a:p>
+            <a:pPr>
+              <a:lnSpc>
+                <a:spcPct val="115000"/>
+              </a:lnSpc>
+              <a:spcAft>
+                <a:spcPts val="600"/>
+              </a:spcAft>
+            </a:pPr>
+            <a:r>
+              <a:rPr sz="1050" b="1">
+                <a:solidFill>
+                  <a:srgbClr val="7C3AED"/>
+                </a:solidFill>
+                <a:latin typeface="Malgun Gothic"/>
+              </a:rPr>
+              <a:t>● </a:t>
+            </a:r>
+            <a:r>
+              <a:rPr sz="1250">
+                <a:solidFill>
+                  <a:srgbClr val="334155"/>
+                </a:solidFill>
+                <a:latin typeface="Malgun Gothic"/>
+              </a:rPr>
+              <a:t>The assistant answers and guides you to the right menu.</a:t>
+            </a:r>
+          </a:p>
+          <a:p>
+            <a:pPr>
+              <a:lnSpc>
+                <a:spcPct val="115000"/>
+              </a:lnSpc>
+              <a:spcAft>
+                <a:spcPts val="600"/>
+              </a:spcAft>
+            </a:pPr>
+            <a:r>
+              <a:rPr sz="1050" b="1">
+                <a:solidFill>
+                  <a:srgbClr val="7C3AED"/>
+                </a:solidFill>
+                <a:latin typeface="Malgun Gothic"/>
+              </a:rPr>
+              <a:t>● </a:t>
+            </a:r>
+            <a:r>
+              <a:rPr sz="1250">
+                <a:solidFill>
+                  <a:srgbClr val="334155"/>
+                </a:solidFill>
+                <a:latin typeface="Malgun Gothic"/>
+              </a:rPr>
+              <a:t>You can also speak your question using the 🎤 mic.</a:t>
+            </a:r>
+          </a:p>
+        </p:txBody>
+      </p:sp>
+      <p:sp>
+        <p:nvSpPr>
+          <p:cNvPr id="14" name="Rounded Rectangle 13"/>
+          <p:cNvSpPr/>
+          <p:nvPr/>
+        </p:nvSpPr>
+        <p:spPr>
+          <a:xfrm>
+            <a:off x="457200" y="4782312"/>
+            <a:ext cx="5669280" cy="1005840"/>
+          </a:xfrm>
+          <a:prstGeom prst="roundRect">
+            <a:avLst/>
+          </a:prstGeom>
+          <a:solidFill>
+            <a:srgbClr val="F4F7FF"/>
+          </a:solidFill>
+          <a:ln w="12700">
+            <a:solidFill>
+              <a:srgbClr val="7C3AED"/>
+            </a:solidFill>
+          </a:ln>
+          <a:effectLst/>
+        </p:spPr>
+        <p:style>
+          <a:lnRef idx="1">
+            <a:schemeClr val="accent1"/>
+          </a:lnRef>
+          <a:fillRef idx="3">
+            <a:schemeClr val="accent1"/>
+          </a:fillRef>
+          <a:effectRef idx="2">
+            <a:schemeClr val="accent1"/>
+          </a:effectRef>
+          <a:fontRef idx="minor">
+            <a:schemeClr val="lt1"/>
+          </a:fontRef>
+        </p:style>
+        <p:txBody>
+          <a:bodyPr rtlCol="0" anchor="ctr"/>
+          <a:lstStyle/>
+          <a:p>
+            <a:pPr algn="ctr"/>
+          </a:p>
+        </p:txBody>
+      </p:sp>
+      <p:sp>
+        <p:nvSpPr>
+          <p:cNvPr id="15" name="TextBox 14"/>
+          <p:cNvSpPr txBox="1"/>
+          <p:nvPr/>
+        </p:nvSpPr>
+        <p:spPr>
+          <a:xfrm>
+            <a:off x="594360" y="4837175"/>
+            <a:ext cx="5394960" cy="274320"/>
+          </a:xfrm>
+          <a:prstGeom prst="rect">
+            <a:avLst/>
+          </a:prstGeom>
+          <a:noFill/>
+        </p:spPr>
+        <p:txBody>
+          <a:bodyPr wrap="square" anchor="t">
+            <a:spAutoFit/>
+          </a:bodyPr>
+          <a:lstStyle/>
+          <a:p>
+            <a:pPr algn="l">
+              <a:lnSpc>
+                <a:spcPct val="100000"/>
+              </a:lnSpc>
+            </a:pPr>
+            <a:r>
+              <a:rPr sz="1150" b="1">
+                <a:solidFill>
+                  <a:srgbClr val="7C3AED"/>
+                </a:solidFill>
+                <a:latin typeface="Malgun Gothic"/>
+              </a:rPr>
+              <a:t>✅ Key Points</a:t>
+            </a:r>
+          </a:p>
+        </p:txBody>
+      </p:sp>
+      <p:sp>
+        <p:nvSpPr>
+          <p:cNvPr id="16" name="TextBox 15"/>
+          <p:cNvSpPr txBox="1"/>
+          <p:nvPr/>
+        </p:nvSpPr>
+        <p:spPr>
+          <a:xfrm>
+            <a:off x="594360" y="5111496"/>
+            <a:ext cx="5394960" cy="640080"/>
+          </a:xfrm>
+          <a:prstGeom prst="rect">
+            <a:avLst/>
+          </a:prstGeom>
+          <a:noFill/>
+        </p:spPr>
+        <p:txBody>
+          <a:bodyPr wrap="square">
+            <a:spAutoFit/>
+          </a:bodyPr>
+          <a:lstStyle/>
+          <a:p>
+            <a:pPr>
+              <a:lnSpc>
+                <a:spcPct val="115000"/>
+              </a:lnSpc>
+              <a:spcAft>
+                <a:spcPts val="200"/>
+              </a:spcAft>
+            </a:pPr>
+            <a:r>
+              <a:rPr sz="900" b="1">
+                <a:solidFill>
+                  <a:srgbClr val="7C3AED"/>
+                </a:solidFill>
+                <a:latin typeface="Malgun Gothic"/>
+              </a:rPr>
+              <a:t>● </a:t>
+            </a:r>
+            <a:r>
+              <a:rPr sz="1100">
+                <a:solidFill>
+                  <a:srgbClr val="334155"/>
+                </a:solidFill>
+                <a:latin typeface="Malgun Gothic"/>
+              </a:rPr>
+              <a:t>Points you straight to features like student games, pronunciation coach, or voice diary.</a:t>
+            </a:r>
+          </a:p>
+          <a:p>
+            <a:pPr>
+              <a:lnSpc>
+                <a:spcPct val="115000"/>
+              </a:lnSpc>
+              <a:spcAft>
+                <a:spcPts val="200"/>
+              </a:spcAft>
+            </a:pPr>
+            <a:r>
+              <a:rPr sz="900" b="1">
+                <a:solidFill>
+                  <a:srgbClr val="7C3AED"/>
+                </a:solidFill>
+                <a:latin typeface="Malgun Gothic"/>
+              </a:rPr>
+              <a:t>● </a:t>
+            </a:r>
+            <a:r>
+              <a:rPr sz="1100">
+                <a:solidFill>
+                  <a:srgbClr val="334155"/>
+                </a:solidFill>
+                <a:latin typeface="Malgun Gothic"/>
+              </a:rPr>
+              <a:t>Available anytime (nights &amp; weekends too) so you can use everything on your own.</a:t>
+            </a:r>
+          </a:p>
+        </p:txBody>
+      </p:sp>
+      <p:sp>
+        <p:nvSpPr>
+          <p:cNvPr id="17" name="Rounded Rectangle 16"/>
+          <p:cNvSpPr/>
+          <p:nvPr/>
+        </p:nvSpPr>
+        <p:spPr>
+          <a:xfrm>
+            <a:off x="457200" y="5897879"/>
+            <a:ext cx="5669280" cy="640080"/>
+          </a:xfrm>
+          <a:prstGeom prst="roundRect">
+            <a:avLst/>
+          </a:prstGeom>
+          <a:solidFill>
+            <a:srgbClr val="FFFBEB"/>
+          </a:solidFill>
+          <a:ln w="12700">
+            <a:solidFill>
+              <a:srgbClr val="F59E0B"/>
+            </a:solidFill>
+          </a:ln>
+          <a:effectLst/>
+        </p:spPr>
+        <p:style>
+          <a:lnRef idx="1">
+            <a:schemeClr val="accent1"/>
+          </a:lnRef>
+          <a:fillRef idx="3">
+            <a:schemeClr val="accent1"/>
+          </a:fillRef>
+          <a:effectRef idx="2">
+            <a:schemeClr val="accent1"/>
+          </a:effectRef>
+          <a:fontRef idx="minor">
+            <a:schemeClr val="lt1"/>
+          </a:fontRef>
+        </p:style>
+        <p:txBody>
+          <a:bodyPr rtlCol="0" anchor="ctr"/>
+          <a:lstStyle/>
+          <a:p>
+            <a:pPr algn="ctr"/>
+          </a:p>
+        </p:txBody>
+      </p:sp>
+      <p:sp>
+        <p:nvSpPr>
+          <p:cNvPr id="18" name="TextBox 17"/>
+          <p:cNvSpPr txBox="1"/>
+          <p:nvPr/>
+        </p:nvSpPr>
+        <p:spPr>
+          <a:xfrm>
+            <a:off x="594360" y="5943599"/>
+            <a:ext cx="5394960" cy="548640"/>
+          </a:xfrm>
+          <a:prstGeom prst="rect">
+            <a:avLst/>
+          </a:prstGeom>
+          <a:noFill/>
+        </p:spPr>
+        <p:txBody>
+          <a:bodyPr wrap="square" anchor="t">
+            <a:spAutoFit/>
+          </a:bodyPr>
+          <a:lstStyle/>
+          <a:p>
+            <a:pPr algn="l">
+              <a:lnSpc>
+                <a:spcPct val="105000"/>
+              </a:lnSpc>
+            </a:pPr>
+            <a:r>
+              <a:rPr sz="1050" b="0">
+                <a:solidFill>
+                  <a:srgbClr val="92670A"/>
+                </a:solidFill>
+                <a:latin typeface="Malgun Gothic"/>
+              </a:rPr>
+              <a:t>⚠️ Good to know · Requests that need a human — billing, operations — are routed to KakaoTalk chat or customer support.</a:t>
+            </a:r>
+          </a:p>
+        </p:txBody>
+      </p:sp>
+      <p:sp>
+        <p:nvSpPr>
+          <p:cNvPr id="19" name="Rounded Rectangle 18"/>
+          <p:cNvSpPr/>
+          <p:nvPr/>
+        </p:nvSpPr>
+        <p:spPr>
+          <a:xfrm>
+            <a:off x="457200" y="6629399"/>
+            <a:ext cx="5669280" cy="658368"/>
+          </a:xfrm>
+          <a:prstGeom prst="roundRect">
+            <a:avLst/>
+          </a:prstGeom>
+          <a:solidFill>
+            <a:srgbClr val="FFF7E6"/>
+          </a:solidFill>
+          <a:ln w="12700">
+            <a:solidFill>
+              <a:srgbClr val="FF9F1C"/>
+            </a:solidFill>
+          </a:ln>
+          <a:effectLst/>
+        </p:spPr>
+        <p:style>
+          <a:lnRef idx="1">
+            <a:schemeClr val="accent1"/>
+          </a:lnRef>
+          <a:fillRef idx="3">
+            <a:schemeClr val="accent1"/>
+          </a:fillRef>
+          <a:effectRef idx="2">
+            <a:schemeClr val="accent1"/>
+          </a:effectRef>
+          <a:fontRef idx="minor">
+            <a:schemeClr val="lt1"/>
+          </a:fontRef>
+        </p:style>
+        <p:txBody>
+          <a:bodyPr rtlCol="0" anchor="ctr"/>
+          <a:lstStyle/>
+          <a:p>
+            <a:pPr algn="ctr"/>
+          </a:p>
+        </p:txBody>
+      </p:sp>
+      <p:sp>
+        <p:nvSpPr>
+          <p:cNvPr id="20" name="TextBox 19"/>
+          <p:cNvSpPr txBox="1"/>
+          <p:nvPr/>
+        </p:nvSpPr>
+        <p:spPr>
+          <a:xfrm>
+            <a:off x="594360" y="6675119"/>
+            <a:ext cx="5394960" cy="566928"/>
+          </a:xfrm>
+          <a:prstGeom prst="rect">
+            <a:avLst/>
+          </a:prstGeom>
+          <a:noFill/>
+        </p:spPr>
+        <p:txBody>
+          <a:bodyPr wrap="square" anchor="t">
+            <a:spAutoFit/>
+          </a:bodyPr>
+          <a:lstStyle/>
+          <a:p>
+            <a:pPr algn="l">
+              <a:lnSpc>
+                <a:spcPct val="105000"/>
+              </a:lnSpc>
+            </a:pPr>
+            <a:r>
+              <a:rPr sz="1050" b="0">
+                <a:solidFill>
+                  <a:srgbClr val="5B4A2A"/>
+                </a:solidFill>
+                <a:latin typeface="Malgun Gothic"/>
+              </a:rPr>
+              <a:t>💡 Tip · Say what you want to do, like “I want to ○○,” and it takes you to that screen.</a:t>
+            </a:r>
+          </a:p>
+        </p:txBody>
+      </p:sp>
+      <p:sp>
+        <p:nvSpPr>
+          <p:cNvPr id="21" name="Rectangle 20"/>
+          <p:cNvSpPr/>
+          <p:nvPr/>
+        </p:nvSpPr>
+        <p:spPr>
+          <a:xfrm>
+            <a:off x="6300216" y="2345436"/>
+            <a:ext cx="5596128" cy="3538728"/>
+          </a:xfrm>
+          <a:prstGeom prst="rect">
+            <a:avLst/>
+          </a:prstGeom>
+          <a:solidFill>
+            <a:srgbClr val="FFFFFF"/>
+          </a:solidFill>
+          <a:ln w="12700">
+            <a:solidFill>
+              <a:srgbClr val="E2E8F0"/>
+            </a:solidFill>
+          </a:ln>
+          <a:effectLst/>
+        </p:spPr>
+        <p:style>
+          <a:lnRef idx="1">
+            <a:schemeClr val="accent1"/>
+          </a:lnRef>
+          <a:fillRef idx="3">
+            <a:schemeClr val="accent1"/>
+          </a:fillRef>
+          <a:effectRef idx="2">
+            <a:schemeClr val="accent1"/>
+          </a:effectRef>
+          <a:fontRef idx="minor">
+            <a:schemeClr val="lt1"/>
+          </a:fontRef>
+        </p:style>
+        <p:txBody>
+          <a:bodyPr rtlCol="0" anchor="ctr"/>
+          <a:lstStyle/>
+          <a:p>
+            <a:pPr algn="ctr"/>
+          </a:p>
+        </p:txBody>
+      </p:sp>
+      <p:pic>
+        <p:nvPicPr>
+          <p:cNvPr id="22" name="Picture 21" descr="student_aiavatar.jpg"/>
+          <p:cNvPicPr>
+            <a:picLocks noChangeAspect="1"/>
+          </p:cNvPicPr>
+          <p:nvPr/>
+        </p:nvPicPr>
+        <p:blipFill>
+          <a:blip r:embed="rId2"/>
+          <a:stretch>
+            <a:fillRect/>
+          </a:stretch>
+        </p:blipFill>
+        <p:spPr>
+          <a:xfrm>
+            <a:off x="6355080" y="2400300"/>
+            <a:ext cx="5486400" cy="3429000"/>
+          </a:xfrm>
+          <a:prstGeom prst="rect">
+            <a:avLst/>
+          </a:prstGeom>
+        </p:spPr>
+      </p:pic>
+    </p:spTree>
+  </p:cSld>
+  <p:clrMapOvr>
+    <a:masterClrMapping/>
+  </p:clrMapOvr>
+</p:sld>
+</file>
+
+<file path=ppt/slides/slide43.xml><?xml version="1.0" encoding="utf-8"?>
 <p:sld xmlns:a="http://schemas.openxmlformats.org/drawingml/2006/main" xmlns:p="http://schemas.openxmlformats.org/presentationml/2006/main" xmlns:r="http://schemas.openxmlformats.org/officeDocument/2006/relationships">
   <p:cSld>
     <p:bg>
@@ -36846,7 +39862,7 @@
 </p:sld>
 </file>
 
-<file path=ppt/slides/slide41.xml><?xml version="1.0" encoding="utf-8"?>
+<file path=ppt/slides/slide44.xml><?xml version="1.0" encoding="utf-8"?>
 <p:sld xmlns:a="http://schemas.openxmlformats.org/drawingml/2006/main" xmlns:p="http://schemas.openxmlformats.org/presentationml/2006/main" xmlns:r="http://schemas.openxmlformats.org/officeDocument/2006/relationships">
   <p:cSld>
     <p:bg>
@@ -37191,7 +40207,7 @@
 </p:sld>
 </file>
 
-<file path=ppt/slides/slide42.xml><?xml version="1.0" encoding="utf-8"?>
+<file path=ppt/slides/slide45.xml><?xml version="1.0" encoding="utf-8"?>
 <p:sld xmlns:a="http://schemas.openxmlformats.org/drawingml/2006/main" xmlns:p="http://schemas.openxmlformats.org/presentationml/2006/main" xmlns:r="http://schemas.openxmlformats.org/officeDocument/2006/relationships">
   <p:cSld>
     <p:bg>
@@ -38166,7 +41182,7 @@
 </p:sld>
 </file>
 
-<file path=ppt/slides/slide43.xml><?xml version="1.0" encoding="utf-8"?>
+<file path=ppt/slides/slide46.xml><?xml version="1.0" encoding="utf-8"?>
 <p:sld xmlns:a="http://schemas.openxmlformats.org/drawingml/2006/main" xmlns:p="http://schemas.openxmlformats.org/presentationml/2006/main" xmlns:r="http://schemas.openxmlformats.org/officeDocument/2006/relationships">
   <p:cSld>
     <p:bg>
@@ -39016,7 +42032,7 @@
 </p:sld>
 </file>
 
-<file path=ppt/slides/slide44.xml><?xml version="1.0" encoding="utf-8"?>
+<file path=ppt/slides/slide47.xml><?xml version="1.0" encoding="utf-8"?>
 <p:sld xmlns:a="http://schemas.openxmlformats.org/drawingml/2006/main" xmlns:p="http://schemas.openxmlformats.org/presentationml/2006/main" xmlns:r="http://schemas.openxmlformats.org/officeDocument/2006/relationships">
   <p:cSld>
     <p:bg>
@@ -40440,7 +43456,7 @@
 </p:sld>
 </file>
 
-<file path=ppt/slides/slide45.xml><?xml version="1.0" encoding="utf-8"?>
+<file path=ppt/slides/slide48.xml><?xml version="1.0" encoding="utf-8"?>
 <p:sld xmlns:a="http://schemas.openxmlformats.org/drawingml/2006/main" xmlns:p="http://schemas.openxmlformats.org/presentationml/2006/main" xmlns:r="http://schemas.openxmlformats.org/officeDocument/2006/relationships">
   <p:cSld>
     <p:bg>

</xml_diff>